<commit_message>
Add dates for completed interactives
Co-Authored-By: Claude Opus 5.5 <noreply@anthropic.com>
Claude-Session: https://claude.ai/code/session_01XnECCStxZTRunjSaWV1VGN
</commit_message>
<xml_diff>
--- a/deck/Our_support_during_the_CV_Phase.pptx
+++ b/deck/Our_support_during_the_CV_Phase.pptx
@@ -22494,7 +22494,7 @@
                           </a:solidFill>
                           <a:latin typeface="Poppins"/>
                         </a:rPr>
-                        <a:t/>
+                        <a:t>Tue 22 Sep</a:t>
                       </a:r>
                     </a:p>
                   </a:txBody>
@@ -22671,7 +22671,7 @@
                           </a:solidFill>
                           <a:latin typeface="Poppins"/>
                         </a:rPr>
-                        <a:t/>
+                        <a:t>Wed 23 Sep</a:t>
                       </a:r>
                     </a:p>
                   </a:txBody>
@@ -22848,7 +22848,7 @@
                           </a:solidFill>
                           <a:latin typeface="Poppins"/>
                         </a:rPr>
-                        <a:t/>
+                        <a:t>Tue 13 Oct</a:t>
                       </a:r>
                     </a:p>
                   </a:txBody>
@@ -23025,7 +23025,7 @@
                           </a:solidFill>
                           <a:latin typeface="Poppins"/>
                         </a:rPr>
-                        <a:t/>
+                        <a:t>Tue 6 Oct</a:t>
                       </a:r>
                     </a:p>
                   </a:txBody>
@@ -23204,6 +23204,7 @@
                         </a:rPr>
                         <a:t/>
                       </a:r>
+                      <a:endParaRPr sz="1100"/>
                     </a:p>
                   </a:txBody>
                   <a:tcPr marL="73152" marR="73152" marT="18288" marB="18288" anchor="ctr">
@@ -23379,7 +23380,7 @@
                           </a:solidFill>
                           <a:latin typeface="Poppins"/>
                         </a:rPr>
-                        <a:t/>
+                        <a:t>Thu 1 Oct</a:t>
                       </a:r>
                     </a:p>
                   </a:txBody>
@@ -23556,7 +23557,7 @@
                           </a:solidFill>
                           <a:latin typeface="Poppins"/>
                         </a:rPr>
-                        <a:t/>
+                        <a:t>Thu 15 Oct</a:t>
                       </a:r>
                     </a:p>
                   </a:txBody>
@@ -23733,7 +23734,7 @@
                           </a:solidFill>
                           <a:latin typeface="Poppins"/>
                         </a:rPr>
-                        <a:t/>
+                        <a:t>Thu 8 Oct</a:t>
                       </a:r>
                     </a:p>
                   </a:txBody>
@@ -24911,6 +24912,1988 @@
               <a:buNone/>
             </a:pPr>
             <a:r>
+              <a:rPr lang="en-US" dirty="0"/>
+              <a:t>Four lessons from the C&amp;V Phase</a:t>
+            </a:r>
+            <a:endParaRPr lang="en-US" sz="2800" dirty="0"/>
+          </a:p>
+        </p:txBody>
+      </p:sp>
+      <p:sp>
+        <p:nvSpPr>
+          <p:cNvPr id="25" name="Slide Number Placeholder 0"/>
+          <p:cNvSpPr>
+            <a:spLocks noGrp="1"/>
+          </p:cNvSpPr>
+          <p:nvPr>
+            <p:ph type="sldNum" sz="quarter" idx="4294967295"/>
+          </p:nvPr>
+        </p:nvSpPr>
+        <p:spPr>
+          <a:xfrm>
+            <a:off x="11256264" y="6327648"/>
+            <a:ext cx="384048" cy="274320"/>
+          </a:xfrm>
+          <a:prstGeom prst="rect">
+            <a:avLst/>
+          </a:prstGeom>
+          <a:extLst>
+            <a:ext uri="{C572A759-6A51-4108-AA02-DFA0A04FC94B}">
+              <ma14:wrappingTextBoxFlag xmlns:ma14="http://schemas.microsoft.com/office/mac/drawingml/2011/main" xmlns="" val="0"/>
+            </a:ext>
+          </a:extLst>
+        </p:spPr>
+        <p:txBody>
+          <a:bodyPr lIns="0" tIns="0" rIns="0" bIns="0" anchor="ctr"/>
+          <a:lstStyle>
+            <a:lvl1pPr>
+              <a:defRPr sz="1000">
+                <a:solidFill>
+                  <a:srgbClr val="FFFFFF"/>
+                </a:solidFill>
+              </a:defRPr>
+            </a:lvl1pPr>
+          </a:lstStyle>
+          <a:p>
+            <a:pPr marL="0" marR="0" lvl="0" indent="0" algn="ctr" defTabSz="914400" rtl="0" eaLnBrk="1" fontAlgn="auto" latinLnBrk="0" hangingPunct="1">
+              <a:lnSpc>
+                <a:spcPct val="100000"/>
+              </a:lnSpc>
+              <a:spcBef>
+                <a:spcPts val="0"/>
+              </a:spcBef>
+              <a:spcAft>
+                <a:spcPts val="0"/>
+              </a:spcAft>
+              <a:buClrTx/>
+              <a:buSzTx/>
+              <a:buFontTx/>
+              <a:buNone/>
+              <a:tabLst/>
+              <a:defRPr/>
+            </a:pPr>
+            <a:fld id="{F7021451-1387-4CA6-816F-3879F97B5CBC}" type="slidenum">
+              <a:rPr kumimoji="0" lang="en-US" sz="1000" b="0" i="0" u="none" strike="noStrike" kern="1200" cap="none" spc="0" normalizeH="0" baseline="0" noProof="0">
+                <a:ln>
+                  <a:noFill/>
+                </a:ln>
+                <a:solidFill>
+                  <a:srgbClr val="FFFFFF"/>
+                </a:solidFill>
+                <a:effectLst/>
+                <a:uLnTx/>
+                <a:uFillTx/>
+                <a:latin typeface="Poppins"/>
+                <a:ea typeface="+mn-ea"/>
+                <a:cs typeface="+mn-cs"/>
+              </a:rPr>
+              <a:pPr marL="0" marR="0" lvl="0" indent="0" algn="ctr" defTabSz="914400" rtl="0" eaLnBrk="1" fontAlgn="auto" latinLnBrk="0" hangingPunct="1">
+                <a:lnSpc>
+                  <a:spcPct val="100000"/>
+                </a:lnSpc>
+                <a:spcBef>
+                  <a:spcPts val="0"/>
+                </a:spcBef>
+                <a:spcAft>
+                  <a:spcPts val="0"/>
+                </a:spcAft>
+                <a:buClrTx/>
+                <a:buSzTx/>
+                <a:buFontTx/>
+                <a:buNone/>
+                <a:tabLst/>
+                <a:defRPr/>
+              </a:pPr>
+              <a:t>8</a:t>
+            </a:fld>
+            <a:endParaRPr kumimoji="0" lang="en-US" sz="1000" b="0" i="0" u="none" strike="noStrike" kern="1200" cap="none" spc="0" normalizeH="0" baseline="0" noProof="0">
+              <a:ln>
+                <a:noFill/>
+              </a:ln>
+              <a:solidFill>
+                <a:srgbClr val="FFFFFF"/>
+              </a:solidFill>
+              <a:effectLst/>
+              <a:uLnTx/>
+              <a:uFillTx/>
+              <a:latin typeface="Poppins"/>
+              <a:ea typeface="+mn-ea"/>
+              <a:cs typeface="+mn-cs"/>
+            </a:endParaRPr>
+          </a:p>
+        </p:txBody>
+      </p:sp>
+      <p:sp>
+        <p:nvSpPr>
+          <p:cNvPr id="26" name="TextBox 25"/>
+          <p:cNvSpPr txBox="1"/>
+          <p:nvPr/>
+        </p:nvSpPr>
+        <p:spPr>
+          <a:xfrm>
+            <a:off x="1417320" y="1481328"/>
+            <a:ext cx="3108960" cy="256032"/>
+          </a:xfrm>
+          <a:prstGeom prst="rect">
+            <a:avLst/>
+          </a:prstGeom>
+          <a:noFill/>
+        </p:spPr>
+        <p:txBody>
+          <a:bodyPr wrap="square" lIns="0" rIns="0" tIns="0" bIns="0" anchor="t">
+            <a:spAutoFit/>
+          </a:bodyPr>
+          <a:lstStyle/>
+          <a:p>
+            <a:pPr algn="l"/>
+            <a:r>
+              <a:rPr sz="1050" b="1" i="0" spc="150">
+                <a:solidFill>
+                  <a:srgbClr val="6E7178"/>
+                </a:solidFill>
+                <a:latin typeface="Poppins"/>
+              </a:rPr>
+              <a:t>LESSON</a:t>
+            </a:r>
+          </a:p>
+        </p:txBody>
+      </p:sp>
+      <p:sp>
+        <p:nvSpPr>
+          <p:cNvPr id="27" name="TextBox 26"/>
+          <p:cNvSpPr txBox="1"/>
+          <p:nvPr/>
+        </p:nvSpPr>
+        <p:spPr>
+          <a:xfrm>
+            <a:off x="4709160" y="1481328"/>
+            <a:ext cx="3383280" cy="256032"/>
+          </a:xfrm>
+          <a:prstGeom prst="rect">
+            <a:avLst/>
+          </a:prstGeom>
+          <a:noFill/>
+        </p:spPr>
+        <p:txBody>
+          <a:bodyPr wrap="square" lIns="0" rIns="0" tIns="0" bIns="0" anchor="t">
+            <a:spAutoFit/>
+          </a:bodyPr>
+          <a:lstStyle/>
+          <a:p>
+            <a:pPr algn="l"/>
+            <a:r>
+              <a:rPr sz="1050" b="1" i="0" spc="150">
+                <a:solidFill>
+                  <a:srgbClr val="6E7178"/>
+                </a:solidFill>
+                <a:latin typeface="Poppins"/>
+              </a:rPr>
+              <a:t>WHAT IT MEANS</a:t>
+            </a:r>
+          </a:p>
+        </p:txBody>
+      </p:sp>
+      <p:sp>
+        <p:nvSpPr>
+          <p:cNvPr id="28" name="TextBox 27"/>
+          <p:cNvSpPr txBox="1"/>
+          <p:nvPr/>
+        </p:nvSpPr>
+        <p:spPr>
+          <a:xfrm>
+            <a:off x="8366760" y="1481328"/>
+            <a:ext cx="3273552" cy="256032"/>
+          </a:xfrm>
+          <a:prstGeom prst="rect">
+            <a:avLst/>
+          </a:prstGeom>
+          <a:noFill/>
+        </p:spPr>
+        <p:txBody>
+          <a:bodyPr wrap="square" lIns="0" rIns="0" tIns="0" bIns="0" anchor="t">
+            <a:spAutoFit/>
+          </a:bodyPr>
+          <a:lstStyle/>
+          <a:p>
+            <a:pPr algn="l"/>
+            <a:r>
+              <a:rPr sz="1050" b="1" i="0" spc="150">
+                <a:solidFill>
+                  <a:srgbClr val="6E7178"/>
+                </a:solidFill>
+                <a:latin typeface="Poppins"/>
+              </a:rPr>
+              <a:t>IN PRACTICE</a:t>
+            </a:r>
+          </a:p>
+        </p:txBody>
+      </p:sp>
+      <p:cxnSp>
+        <p:nvCxnSpPr>
+          <p:cNvPr id="29" name="Connector 28"/>
+          <p:cNvCxnSpPr/>
+          <p:nvPr/>
+        </p:nvCxnSpPr>
+        <p:spPr>
+          <a:xfrm>
+            <a:off x="548640" y="1801368"/>
+            <a:ext cx="11091672" cy="0"/>
+          </a:xfrm>
+          <a:prstGeom prst="line">
+            <a:avLst/>
+          </a:prstGeom>
+          <a:ln w="12700">
+            <a:solidFill>
+              <a:srgbClr val="3D3C3C"/>
+            </a:solidFill>
+          </a:ln>
+        </p:spPr>
+        <p:style>
+          <a:lnRef idx="2">
+            <a:schemeClr val="accent1"/>
+          </a:lnRef>
+          <a:fillRef idx="0">
+            <a:schemeClr val="accent1"/>
+          </a:fillRef>
+          <a:effectRef idx="1">
+            <a:schemeClr val="accent1"/>
+          </a:effectRef>
+          <a:fontRef idx="minor">
+            <a:schemeClr val="tx1"/>
+          </a:fontRef>
+        </p:style>
+      </p:cxnSp>
+      <p:sp>
+        <p:nvSpPr>
+          <p:cNvPr id="30" name="TextBox 29"/>
+          <p:cNvSpPr txBox="1"/>
+          <p:nvPr/>
+        </p:nvSpPr>
+        <p:spPr>
+          <a:xfrm>
+            <a:off x="548640" y="1892808"/>
+            <a:ext cx="777240" cy="548640"/>
+          </a:xfrm>
+          <a:prstGeom prst="rect">
+            <a:avLst/>
+          </a:prstGeom>
+          <a:noFill/>
+        </p:spPr>
+        <p:txBody>
+          <a:bodyPr wrap="square" lIns="0" rIns="0" tIns="0" bIns="0" anchor="t">
+            <a:spAutoFit/>
+          </a:bodyPr>
+          <a:lstStyle/>
+          <a:p>
+            <a:pPr algn="l"/>
+            <a:r>
+              <a:rPr sz="3000" b="1" i="0">
+                <a:solidFill>
+                  <a:srgbClr val="F48047"/>
+                </a:solidFill>
+                <a:latin typeface="Poppins"/>
+              </a:rPr>
+              <a:t>01</a:t>
+            </a:r>
+          </a:p>
+        </p:txBody>
+      </p:sp>
+      <p:sp>
+        <p:nvSpPr>
+          <p:cNvPr id="31" name="TextBox 30"/>
+          <p:cNvSpPr txBox="1"/>
+          <p:nvPr/>
+        </p:nvSpPr>
+        <p:spPr>
+          <a:xfrm>
+            <a:off x="1417320" y="1938528"/>
+            <a:ext cx="3108960" cy="822960"/>
+          </a:xfrm>
+          <a:prstGeom prst="rect">
+            <a:avLst/>
+          </a:prstGeom>
+          <a:noFill/>
+        </p:spPr>
+        <p:txBody>
+          <a:bodyPr wrap="square" lIns="0" rIns="0" tIns="0" bIns="0" anchor="t">
+            <a:spAutoFit/>
+          </a:bodyPr>
+          <a:lstStyle/>
+          <a:p>
+            <a:pPr algn="l"/>
+            <a:r>
+              <a:rPr sz="1500" b="1" i="0">
+                <a:solidFill>
+                  <a:srgbClr val="3D3C3C"/>
+                </a:solidFill>
+                <a:latin typeface="Poppins"/>
+              </a:rPr>
+              <a:t>Preparation is paramount</a:t>
+            </a:r>
+          </a:p>
+        </p:txBody>
+      </p:sp>
+      <p:sp>
+        <p:nvSpPr>
+          <p:cNvPr id="32" name="TextBox 31"/>
+          <p:cNvSpPr txBox="1"/>
+          <p:nvPr/>
+        </p:nvSpPr>
+        <p:spPr>
+          <a:xfrm>
+            <a:off x="4709160" y="1938528"/>
+            <a:ext cx="3383280" cy="868680"/>
+          </a:xfrm>
+          <a:prstGeom prst="rect">
+            <a:avLst/>
+          </a:prstGeom>
+          <a:noFill/>
+        </p:spPr>
+        <p:txBody>
+          <a:bodyPr wrap="square" lIns="0" rIns="0" tIns="0" bIns="0" anchor="t">
+            <a:spAutoFit/>
+          </a:bodyPr>
+          <a:lstStyle/>
+          <a:p>
+            <a:pPr algn="l"/>
+            <a:r>
+              <a:rPr sz="1150" b="0" i="0">
+                <a:solidFill>
+                  <a:srgbClr val="3D3C3C"/>
+                </a:solidFill>
+                <a:latin typeface="Poppins"/>
+              </a:rPr>
+              <a:t>Thorough preparation gives the team its key messages and puts GoFar in a strong light, even when slides are not presented.</a:t>
+            </a:r>
+          </a:p>
+        </p:txBody>
+      </p:sp>
+      <p:sp>
+        <p:nvSpPr>
+          <p:cNvPr id="33" name="TextBox 32"/>
+          <p:cNvSpPr txBox="1"/>
+          <p:nvPr/>
+        </p:nvSpPr>
+        <p:spPr>
+          <a:xfrm>
+            <a:off x="8366760" y="1938528"/>
+            <a:ext cx="3273552" cy="868680"/>
+          </a:xfrm>
+          <a:prstGeom prst="rect">
+            <a:avLst/>
+          </a:prstGeom>
+          <a:noFill/>
+        </p:spPr>
+        <p:txBody>
+          <a:bodyPr wrap="square" lIns="0" rIns="0" tIns="0" bIns="0" anchor="t">
+            <a:spAutoFit/>
+          </a:bodyPr>
+          <a:lstStyle/>
+          <a:p>
+            <a:pPr algn="l"/>
+            <a:r>
+              <a:rPr sz="1100" b="0" i="1">
+                <a:solidFill>
+                  <a:srgbClr val="6E7178"/>
+                </a:solidFill>
+                <a:latin typeface="Poppins"/>
+              </a:rPr>
+              <a:t>In instances where GoFar doesn't present, the team is still better informed and ready because of the work done beforehand.</a:t>
+            </a:r>
+          </a:p>
+        </p:txBody>
+      </p:sp>
+      <p:cxnSp>
+        <p:nvCxnSpPr>
+          <p:cNvPr id="34" name="Connector 33"/>
+          <p:cNvCxnSpPr/>
+          <p:nvPr/>
+        </p:nvCxnSpPr>
+        <p:spPr>
+          <a:xfrm>
+            <a:off x="548640" y="2926080"/>
+            <a:ext cx="11091672" cy="0"/>
+          </a:xfrm>
+          <a:prstGeom prst="line">
+            <a:avLst/>
+          </a:prstGeom>
+          <a:ln w="9525">
+            <a:solidFill>
+              <a:srgbClr val="D9DBE0"/>
+            </a:solidFill>
+          </a:ln>
+        </p:spPr>
+        <p:style>
+          <a:lnRef idx="2">
+            <a:schemeClr val="accent1"/>
+          </a:lnRef>
+          <a:fillRef idx="0">
+            <a:schemeClr val="accent1"/>
+          </a:fillRef>
+          <a:effectRef idx="1">
+            <a:schemeClr val="accent1"/>
+          </a:effectRef>
+          <a:fontRef idx="minor">
+            <a:schemeClr val="tx1"/>
+          </a:fontRef>
+        </p:style>
+      </p:cxnSp>
+      <p:sp>
+        <p:nvSpPr>
+          <p:cNvPr id="35" name="TextBox 34"/>
+          <p:cNvSpPr txBox="1"/>
+          <p:nvPr/>
+        </p:nvSpPr>
+        <p:spPr>
+          <a:xfrm>
+            <a:off x="548640" y="2990088"/>
+            <a:ext cx="777240" cy="548640"/>
+          </a:xfrm>
+          <a:prstGeom prst="rect">
+            <a:avLst/>
+          </a:prstGeom>
+          <a:noFill/>
+        </p:spPr>
+        <p:txBody>
+          <a:bodyPr wrap="square" lIns="0" rIns="0" tIns="0" bIns="0" anchor="t">
+            <a:spAutoFit/>
+          </a:bodyPr>
+          <a:lstStyle/>
+          <a:p>
+            <a:pPr algn="l"/>
+            <a:r>
+              <a:rPr sz="3000" b="1" i="0">
+                <a:solidFill>
+                  <a:srgbClr val="0E98D7"/>
+                </a:solidFill>
+                <a:latin typeface="Poppins"/>
+              </a:rPr>
+              <a:t>02</a:t>
+            </a:r>
+          </a:p>
+        </p:txBody>
+      </p:sp>
+      <p:sp>
+        <p:nvSpPr>
+          <p:cNvPr id="36" name="TextBox 35"/>
+          <p:cNvSpPr txBox="1"/>
+          <p:nvPr/>
+        </p:nvSpPr>
+        <p:spPr>
+          <a:xfrm>
+            <a:off x="1417320" y="3035808"/>
+            <a:ext cx="3108960" cy="822960"/>
+          </a:xfrm>
+          <a:prstGeom prst="rect">
+            <a:avLst/>
+          </a:prstGeom>
+          <a:noFill/>
+        </p:spPr>
+        <p:txBody>
+          <a:bodyPr wrap="square" lIns="0" rIns="0" tIns="0" bIns="0" anchor="t">
+            <a:spAutoFit/>
+          </a:bodyPr>
+          <a:lstStyle/>
+          <a:p>
+            <a:pPr algn="l"/>
+            <a:r>
+              <a:rPr sz="1500" b="1" i="0">
+                <a:solidFill>
+                  <a:srgbClr val="3D3C3C"/>
+                </a:solidFill>
+                <a:latin typeface="Poppins"/>
+              </a:rPr>
+              <a:t>HSRA values guidance and capability</a:t>
+            </a:r>
+          </a:p>
+        </p:txBody>
+      </p:sp>
+      <p:sp>
+        <p:nvSpPr>
+          <p:cNvPr id="37" name="TextBox 36"/>
+          <p:cNvSpPr txBox="1"/>
+          <p:nvPr/>
+        </p:nvSpPr>
+        <p:spPr>
+          <a:xfrm>
+            <a:off x="4709160" y="3035808"/>
+            <a:ext cx="3383280" cy="868680"/>
+          </a:xfrm>
+          <a:prstGeom prst="rect">
+            <a:avLst/>
+          </a:prstGeom>
+          <a:noFill/>
+        </p:spPr>
+        <p:txBody>
+          <a:bodyPr wrap="square" lIns="0" rIns="0" tIns="0" bIns="0" anchor="t">
+            <a:spAutoFit/>
+          </a:bodyPr>
+          <a:lstStyle/>
+          <a:p>
+            <a:pPr algn="l"/>
+            <a:r>
+              <a:rPr sz="1150" b="0" i="0">
+                <a:solidFill>
+                  <a:srgbClr val="3D3C3C"/>
+                </a:solidFill>
+                <a:latin typeface="Poppins"/>
+              </a:rPr>
+              <a:t>HSRA is looking for as much guidance as possible and responds to partners who bring structure and clarity.</a:t>
+            </a:r>
+          </a:p>
+        </p:txBody>
+      </p:sp>
+      <p:sp>
+        <p:nvSpPr>
+          <p:cNvPr id="38" name="TextBox 37"/>
+          <p:cNvSpPr txBox="1"/>
+          <p:nvPr/>
+        </p:nvSpPr>
+        <p:spPr>
+          <a:xfrm>
+            <a:off x="8366760" y="3035808"/>
+            <a:ext cx="3273552" cy="868680"/>
+          </a:xfrm>
+          <a:prstGeom prst="rect">
+            <a:avLst/>
+          </a:prstGeom>
+          <a:noFill/>
+        </p:spPr>
+        <p:txBody>
+          <a:bodyPr wrap="square" lIns="0" rIns="0" tIns="0" bIns="0" anchor="t">
+            <a:spAutoFit/>
+          </a:bodyPr>
+          <a:lstStyle/>
+          <a:p>
+            <a:pPr algn="l"/>
+            <a:r>
+              <a:rPr sz="1100" b="0" i="1">
+                <a:solidFill>
+                  <a:srgbClr val="6E7178"/>
+                </a:solidFill>
+                <a:latin typeface="Poppins"/>
+              </a:rPr>
+              <a:t>In the Fire and Life Safety workshop, HSRA used GoFar's slides to run the meeting, as we had covered every point on its agenda.</a:t>
+            </a:r>
+          </a:p>
+        </p:txBody>
+      </p:sp>
+      <p:cxnSp>
+        <p:nvCxnSpPr>
+          <p:cNvPr id="39" name="Connector 38"/>
+          <p:cNvCxnSpPr/>
+          <p:nvPr/>
+        </p:nvCxnSpPr>
+        <p:spPr>
+          <a:xfrm>
+            <a:off x="548640" y="4023360"/>
+            <a:ext cx="11091672" cy="0"/>
+          </a:xfrm>
+          <a:prstGeom prst="line">
+            <a:avLst/>
+          </a:prstGeom>
+          <a:ln w="9525">
+            <a:solidFill>
+              <a:srgbClr val="D9DBE0"/>
+            </a:solidFill>
+          </a:ln>
+        </p:spPr>
+        <p:style>
+          <a:lnRef idx="2">
+            <a:schemeClr val="accent1"/>
+          </a:lnRef>
+          <a:fillRef idx="0">
+            <a:schemeClr val="accent1"/>
+          </a:fillRef>
+          <a:effectRef idx="1">
+            <a:schemeClr val="accent1"/>
+          </a:effectRef>
+          <a:fontRef idx="minor">
+            <a:schemeClr val="tx1"/>
+          </a:fontRef>
+        </p:style>
+      </p:cxnSp>
+      <p:sp>
+        <p:nvSpPr>
+          <p:cNvPr id="40" name="TextBox 39"/>
+          <p:cNvSpPr txBox="1"/>
+          <p:nvPr/>
+        </p:nvSpPr>
+        <p:spPr>
+          <a:xfrm>
+            <a:off x="548640" y="4087368"/>
+            <a:ext cx="777240" cy="548640"/>
+          </a:xfrm>
+          <a:prstGeom prst="rect">
+            <a:avLst/>
+          </a:prstGeom>
+          <a:noFill/>
+        </p:spPr>
+        <p:txBody>
+          <a:bodyPr wrap="square" lIns="0" rIns="0" tIns="0" bIns="0" anchor="t">
+            <a:spAutoFit/>
+          </a:bodyPr>
+          <a:lstStyle/>
+          <a:p>
+            <a:pPr algn="l"/>
+            <a:r>
+              <a:rPr sz="3000" b="1" i="0">
+                <a:solidFill>
+                  <a:srgbClr val="2EB88A"/>
+                </a:solidFill>
+                <a:latin typeface="Poppins"/>
+              </a:rPr>
+              <a:t>03</a:t>
+            </a:r>
+          </a:p>
+        </p:txBody>
+      </p:sp>
+      <p:sp>
+        <p:nvSpPr>
+          <p:cNvPr id="41" name="TextBox 40"/>
+          <p:cNvSpPr txBox="1"/>
+          <p:nvPr/>
+        </p:nvSpPr>
+        <p:spPr>
+          <a:xfrm>
+            <a:off x="1417320" y="4133087"/>
+            <a:ext cx="3108960" cy="822960"/>
+          </a:xfrm>
+          <a:prstGeom prst="rect">
+            <a:avLst/>
+          </a:prstGeom>
+          <a:noFill/>
+        </p:spPr>
+        <p:txBody>
+          <a:bodyPr wrap="square" lIns="0" rIns="0" tIns="0" bIns="0" anchor="t">
+            <a:spAutoFit/>
+          </a:bodyPr>
+          <a:lstStyle/>
+          <a:p>
+            <a:pPr algn="l"/>
+            <a:r>
+              <a:rPr sz="1500" b="1" i="0">
+                <a:solidFill>
+                  <a:srgbClr val="3D3C3C"/>
+                </a:solidFill>
+                <a:latin typeface="Poppins"/>
+              </a:rPr>
+              <a:t>Listening builds credibility</a:t>
+            </a:r>
+          </a:p>
+        </p:txBody>
+      </p:sp>
+      <p:sp>
+        <p:nvSpPr>
+          <p:cNvPr id="42" name="TextBox 41"/>
+          <p:cNvSpPr txBox="1"/>
+          <p:nvPr/>
+        </p:nvSpPr>
+        <p:spPr>
+          <a:xfrm>
+            <a:off x="4709160" y="4133087"/>
+            <a:ext cx="3383280" cy="868680"/>
+          </a:xfrm>
+          <a:prstGeom prst="rect">
+            <a:avLst/>
+          </a:prstGeom>
+          <a:noFill/>
+        </p:spPr>
+        <p:txBody>
+          <a:bodyPr wrap="square" lIns="0" rIns="0" tIns="0" bIns="0" anchor="t">
+            <a:spAutoFit/>
+          </a:bodyPr>
+          <a:lstStyle/>
+          <a:p>
+            <a:pPr algn="l"/>
+            <a:r>
+              <a:rPr sz="1150" b="0" i="0">
+                <a:solidFill>
+                  <a:srgbClr val="3D3C3C"/>
+                </a:solidFill>
+                <a:latin typeface="Poppins"/>
+              </a:rPr>
+              <a:t>Responding to what HSRA has asked for, and building on its own work, earns more trust than innovation for its own sake.</a:t>
+            </a:r>
+          </a:p>
+        </p:txBody>
+      </p:sp>
+      <p:sp>
+        <p:nvSpPr>
+          <p:cNvPr id="43" name="TextBox 42"/>
+          <p:cNvSpPr txBox="1"/>
+          <p:nvPr/>
+        </p:nvSpPr>
+        <p:spPr>
+          <a:xfrm>
+            <a:off x="8366760" y="4133087"/>
+            <a:ext cx="3273552" cy="868680"/>
+          </a:xfrm>
+          <a:prstGeom prst="rect">
+            <a:avLst/>
+          </a:prstGeom>
+          <a:noFill/>
+        </p:spPr>
+        <p:txBody>
+          <a:bodyPr wrap="square" lIns="0" rIns="0" tIns="0" bIns="0" anchor="t">
+            <a:spAutoFit/>
+          </a:bodyPr>
+          <a:lstStyle/>
+          <a:p>
+            <a:pPr algn="l"/>
+            <a:r>
+              <a:rPr sz="1100" b="0" i="1">
+                <a:solidFill>
+                  <a:srgbClr val="6E7178"/>
+                </a:solidFill>
+                <a:latin typeface="Poppins"/>
+              </a:rPr>
+              <a:t>The alternative alignment gained support because it built on HSRA's Business Case. Another partner's late, untested idea did not progress.</a:t>
+            </a:r>
+          </a:p>
+        </p:txBody>
+      </p:sp>
+      <p:cxnSp>
+        <p:nvCxnSpPr>
+          <p:cNvPr id="44" name="Connector 43"/>
+          <p:cNvCxnSpPr/>
+          <p:nvPr/>
+        </p:nvCxnSpPr>
+        <p:spPr>
+          <a:xfrm>
+            <a:off x="548640" y="5120640"/>
+            <a:ext cx="11091672" cy="0"/>
+          </a:xfrm>
+          <a:prstGeom prst="line">
+            <a:avLst/>
+          </a:prstGeom>
+          <a:ln w="9525">
+            <a:solidFill>
+              <a:srgbClr val="D9DBE0"/>
+            </a:solidFill>
+          </a:ln>
+        </p:spPr>
+        <p:style>
+          <a:lnRef idx="2">
+            <a:schemeClr val="accent1"/>
+          </a:lnRef>
+          <a:fillRef idx="0">
+            <a:schemeClr val="accent1"/>
+          </a:fillRef>
+          <a:effectRef idx="1">
+            <a:schemeClr val="accent1"/>
+          </a:effectRef>
+          <a:fontRef idx="minor">
+            <a:schemeClr val="tx1"/>
+          </a:fontRef>
+        </p:style>
+      </p:cxnSp>
+      <p:sp>
+        <p:nvSpPr>
+          <p:cNvPr id="45" name="TextBox 44"/>
+          <p:cNvSpPr txBox="1"/>
+          <p:nvPr/>
+        </p:nvSpPr>
+        <p:spPr>
+          <a:xfrm>
+            <a:off x="548640" y="5184648"/>
+            <a:ext cx="777240" cy="548640"/>
+          </a:xfrm>
+          <a:prstGeom prst="rect">
+            <a:avLst/>
+          </a:prstGeom>
+          <a:noFill/>
+        </p:spPr>
+        <p:txBody>
+          <a:bodyPr wrap="square" lIns="0" rIns="0" tIns="0" bIns="0" anchor="t">
+            <a:spAutoFit/>
+          </a:bodyPr>
+          <a:lstStyle/>
+          <a:p>
+            <a:pPr algn="l"/>
+            <a:r>
+              <a:rPr sz="3000" b="1" i="0">
+                <a:solidFill>
+                  <a:srgbClr val="EE2B7A"/>
+                </a:solidFill>
+                <a:latin typeface="Poppins"/>
+              </a:rPr>
+              <a:t>04</a:t>
+            </a:r>
+          </a:p>
+        </p:txBody>
+      </p:sp>
+      <p:sp>
+        <p:nvSpPr>
+          <p:cNvPr id="46" name="TextBox 45"/>
+          <p:cNvSpPr txBox="1"/>
+          <p:nvPr/>
+        </p:nvSpPr>
+        <p:spPr>
+          <a:xfrm>
+            <a:off x="1417320" y="5230368"/>
+            <a:ext cx="3108960" cy="822960"/>
+          </a:xfrm>
+          <a:prstGeom prst="rect">
+            <a:avLst/>
+          </a:prstGeom>
+          <a:noFill/>
+        </p:spPr>
+        <p:txBody>
+          <a:bodyPr wrap="square" lIns="0" rIns="0" tIns="0" bIns="0" anchor="t">
+            <a:spAutoFit/>
+          </a:bodyPr>
+          <a:lstStyle/>
+          <a:p>
+            <a:pPr algn="l"/>
+            <a:r>
+              <a:rPr sz="1500" b="1" i="0">
+                <a:solidFill>
+                  <a:srgbClr val="EE2B7A"/>
+                </a:solidFill>
+                <a:latin typeface="Poppins"/>
+              </a:rPr>
+              <a:t>Our secret sauce: HSRA at the centre</a:t>
+            </a:r>
+          </a:p>
+        </p:txBody>
+      </p:sp>
+      <p:sp>
+        <p:nvSpPr>
+          <p:cNvPr id="47" name="TextBox 46"/>
+          <p:cNvSpPr txBox="1"/>
+          <p:nvPr/>
+        </p:nvSpPr>
+        <p:spPr>
+          <a:xfrm>
+            <a:off x="4709160" y="5230368"/>
+            <a:ext cx="3383280" cy="868680"/>
+          </a:xfrm>
+          <a:prstGeom prst="rect">
+            <a:avLst/>
+          </a:prstGeom>
+          <a:noFill/>
+        </p:spPr>
+        <p:txBody>
+          <a:bodyPr wrap="square" lIns="0" rIns="0" tIns="0" bIns="0" anchor="t">
+            <a:spAutoFit/>
+          </a:bodyPr>
+          <a:lstStyle/>
+          <a:p>
+            <a:pPr algn="l"/>
+            <a:r>
+              <a:rPr sz="1150" b="0" i="0">
+                <a:solidFill>
+                  <a:srgbClr val="3D3C3C"/>
+                </a:solidFill>
+                <a:latin typeface="Poppins"/>
+              </a:rPr>
+              <a:t>Customer centricity sets GoFar apart. Every message starts with what HSRA needs, and we will keep building on it in the ECI.</a:t>
+            </a:r>
+          </a:p>
+        </p:txBody>
+      </p:sp>
+      <p:sp>
+        <p:nvSpPr>
+          <p:cNvPr id="48" name="TextBox 47"/>
+          <p:cNvSpPr txBox="1"/>
+          <p:nvPr/>
+        </p:nvSpPr>
+        <p:spPr>
+          <a:xfrm>
+            <a:off x="8366760" y="5230368"/>
+            <a:ext cx="3273552" cy="868680"/>
+          </a:xfrm>
+          <a:prstGeom prst="rect">
+            <a:avLst/>
+          </a:prstGeom>
+          <a:noFill/>
+        </p:spPr>
+        <p:txBody>
+          <a:bodyPr wrap="square" lIns="0" rIns="0" tIns="0" bIns="0" anchor="t">
+            <a:spAutoFit/>
+          </a:bodyPr>
+          <a:lstStyle/>
+          <a:p>
+            <a:pPr algn="l"/>
+            <a:r>
+              <a:rPr sz="1100" b="0" i="1">
+                <a:solidFill>
+                  <a:srgbClr val="6E7178"/>
+                </a:solidFill>
+                <a:latin typeface="Poppins"/>
+              </a:rPr>
+              <a:t>By linking every point to HSRA's benefit, the alternative alignment became known as the GoFar alignment and gained other partners' support.</a:t>
+            </a:r>
+          </a:p>
+        </p:txBody>
+      </p:sp>
+    </p:spTree>
+  </p:cSld>
+  <p:clrMapOvr>
+    <a:masterClrMapping/>
+  </p:clrMapOvr>
+</p:sld>
+</file>
+
+<file path=ppt/slides/slide7.xml><?xml version="1.0" encoding="utf-8"?>
+<p:sld xmlns:a="http://schemas.openxmlformats.org/drawingml/2006/main" xmlns:r="http://schemas.openxmlformats.org/officeDocument/2006/relationships" xmlns:p="http://schemas.openxmlformats.org/presentationml/2006/main">
+  <p:cSld>
+    <p:spTree>
+      <p:nvGrpSpPr>
+        <p:cNvPr id="1" name=""/>
+        <p:cNvGrpSpPr/>
+        <p:nvPr/>
+      </p:nvGrpSpPr>
+      <p:grpSpPr>
+        <a:xfrm>
+          <a:off x="0" y="0"/>
+          <a:ext cx="0" cy="0"/>
+          <a:chOff x="0" y="0"/>
+          <a:chExt cx="0" cy="0"/>
+        </a:xfrm>
+      </p:grpSpPr>
+      <p:sp>
+        <p:nvSpPr>
+          <p:cNvPr id="3" name="Text 0"/>
+          <p:cNvSpPr>
+            <a:spLocks noGrp="1"/>
+          </p:cNvSpPr>
+          <p:nvPr>
+            <p:ph type="title" idx="101" hasCustomPrompt="1"/>
+          </p:nvPr>
+        </p:nvSpPr>
+        <p:spPr>
+          <a:xfrm>
+            <a:off x="548640" y="658368"/>
+            <a:ext cx="11094415" cy="640080"/>
+          </a:xfrm>
+          <a:prstGeom prst="rect">
+            <a:avLst/>
+          </a:prstGeom>
+          <a:noFill/>
+          <a:ln/>
+        </p:spPr>
+        <p:txBody>
+          <a:bodyPr wrap="square" lIns="0" tIns="0" rIns="0" bIns="0" rtlCol="0" anchor="t"/>
+          <a:lstStyle/>
+          <a:p>
+            <a:r>
+              <a:rPr lang="en-AU" dirty="0"/>
+              <a:t>What we have heard and seen through the C&amp;V Phase</a:t>
+            </a:r>
+            <a:endParaRPr lang="en-US" sz="2800" dirty="0"/>
+          </a:p>
+        </p:txBody>
+      </p:sp>
+      <p:sp>
+        <p:nvSpPr>
+          <p:cNvPr id="32" name="Slide Number Placeholder 0"/>
+          <p:cNvSpPr>
+            <a:spLocks noGrp="1"/>
+          </p:cNvSpPr>
+          <p:nvPr>
+            <p:ph type="sldNum" sz="quarter" idx="4294967295"/>
+          </p:nvPr>
+        </p:nvSpPr>
+        <p:spPr>
+          <a:xfrm>
+            <a:off x="11259007" y="6327648"/>
+            <a:ext cx="384048" cy="274320"/>
+          </a:xfrm>
+          <a:prstGeom prst="rect">
+            <a:avLst/>
+          </a:prstGeom>
+          <a:extLst>
+            <a:ext uri="{C572A759-6A51-4108-AA02-DFA0A04FC94B}">
+              <ma14:wrappingTextBoxFlag xmlns:ma14="http://schemas.microsoft.com/office/mac/drawingml/2011/main" xmlns="" val="0"/>
+            </a:ext>
+          </a:extLst>
+        </p:spPr>
+        <p:txBody>
+          <a:bodyPr lIns="0" tIns="0" rIns="0" bIns="0" anchor="ctr"/>
+          <a:lstStyle>
+            <a:lvl1pPr>
+              <a:defRPr sz="1000">
+                <a:solidFill>
+                  <a:srgbClr val="FFFFFF"/>
+                </a:solidFill>
+              </a:defRPr>
+            </a:lvl1pPr>
+          </a:lstStyle>
+          <a:p>
+            <a:pPr marL="0" marR="0" lvl="0" indent="0" algn="ctr" defTabSz="914400" rtl="0" eaLnBrk="1" fontAlgn="auto" latinLnBrk="0" hangingPunct="1">
+              <a:lnSpc>
+                <a:spcPct val="100000"/>
+              </a:lnSpc>
+              <a:spcBef>
+                <a:spcPts val="0"/>
+              </a:spcBef>
+              <a:spcAft>
+                <a:spcPts val="0"/>
+              </a:spcAft>
+              <a:buClrTx/>
+              <a:buSzTx/>
+              <a:buFontTx/>
+              <a:buNone/>
+              <a:tabLst/>
+              <a:defRPr/>
+            </a:pPr>
+            <a:fld id="{F7021451-1387-4CA6-816F-3879F97B5CBC}" type="slidenum">
+              <a:rPr kumimoji="0" lang="en-US" sz="1000" b="0" i="0" u="none" strike="noStrike" kern="1200" cap="none" spc="0" normalizeH="0" baseline="0" noProof="0">
+                <a:ln>
+                  <a:noFill/>
+                </a:ln>
+                <a:solidFill>
+                  <a:srgbClr val="FFFFFF"/>
+                </a:solidFill>
+                <a:effectLst/>
+                <a:uLnTx/>
+                <a:uFillTx/>
+                <a:latin typeface="Poppins"/>
+                <a:ea typeface="+mn-ea"/>
+                <a:cs typeface="+mn-cs"/>
+              </a:rPr>
+              <a:pPr marL="0" marR="0" lvl="0" indent="0" algn="ctr" defTabSz="914400" rtl="0" eaLnBrk="1" fontAlgn="auto" latinLnBrk="0" hangingPunct="1">
+                <a:lnSpc>
+                  <a:spcPct val="100000"/>
+                </a:lnSpc>
+                <a:spcBef>
+                  <a:spcPts val="0"/>
+                </a:spcBef>
+                <a:spcAft>
+                  <a:spcPts val="0"/>
+                </a:spcAft>
+                <a:buClrTx/>
+                <a:buSzTx/>
+                <a:buFontTx/>
+                <a:buNone/>
+                <a:tabLst/>
+                <a:defRPr/>
+              </a:pPr>
+              <a:t>9</a:t>
+            </a:fld>
+            <a:endParaRPr kumimoji="0" lang="en-US" sz="1000" b="0" i="0" u="none" strike="noStrike" kern="1200" cap="none" spc="0" normalizeH="0" baseline="0" noProof="0">
+              <a:ln>
+                <a:noFill/>
+              </a:ln>
+              <a:solidFill>
+                <a:srgbClr val="FFFFFF"/>
+              </a:solidFill>
+              <a:effectLst/>
+              <a:uLnTx/>
+              <a:uFillTx/>
+              <a:latin typeface="Poppins"/>
+              <a:ea typeface="+mn-ea"/>
+              <a:cs typeface="+mn-cs"/>
+            </a:endParaRPr>
+          </a:p>
+        </p:txBody>
+      </p:sp>
+      <p:sp>
+        <p:nvSpPr>
+          <p:cNvPr id="33" name="TextBox 32"/>
+          <p:cNvSpPr txBox="1"/>
+          <p:nvPr/>
+        </p:nvSpPr>
+        <p:spPr>
+          <a:xfrm>
+            <a:off x="548640" y="1234440"/>
+            <a:ext cx="11091672" cy="365760"/>
+          </a:xfrm>
+          <a:prstGeom prst="rect">
+            <a:avLst/>
+          </a:prstGeom>
+          <a:noFill/>
+        </p:spPr>
+        <p:txBody>
+          <a:bodyPr wrap="square" lIns="0" rIns="0" tIns="0" bIns="0" anchor="t">
+            <a:spAutoFit/>
+          </a:bodyPr>
+          <a:lstStyle/>
+          <a:p>
+            <a:pPr algn="l"/>
+            <a:r>
+              <a:rPr sz="1400" b="0" i="0">
+                <a:solidFill>
+                  <a:srgbClr val="6E7178"/>
+                </a:solidFill>
+                <a:latin typeface="Poppins"/>
+              </a:rPr>
+              <a:t>The JV has made strong progress. A few changes now will set the team up well for the ECI Phase.</a:t>
+            </a:r>
+          </a:p>
+        </p:txBody>
+      </p:sp>
+      <p:sp>
+        <p:nvSpPr>
+          <p:cNvPr id="34" name="TextBox 33"/>
+          <p:cNvSpPr txBox="1"/>
+          <p:nvPr/>
+        </p:nvSpPr>
+        <p:spPr>
+          <a:xfrm>
+            <a:off x="548640" y="1828800"/>
+            <a:ext cx="3566160" cy="256032"/>
+          </a:xfrm>
+          <a:prstGeom prst="rect">
+            <a:avLst/>
+          </a:prstGeom>
+          <a:noFill/>
+        </p:spPr>
+        <p:txBody>
+          <a:bodyPr wrap="square" lIns="0" rIns="0" tIns="0" bIns="0" anchor="t">
+            <a:spAutoFit/>
+          </a:bodyPr>
+          <a:lstStyle/>
+          <a:p>
+            <a:pPr algn="l"/>
+            <a:r>
+              <a:rPr sz="1050" b="1" i="0" spc="150">
+                <a:solidFill>
+                  <a:srgbClr val="2EB88A"/>
+                </a:solidFill>
+                <a:latin typeface="Poppins"/>
+              </a:rPr>
+              <a:t>WHAT IS WORKING</a:t>
+            </a:r>
+          </a:p>
+        </p:txBody>
+      </p:sp>
+      <p:cxnSp>
+        <p:nvCxnSpPr>
+          <p:cNvPr id="35" name="Connector 34"/>
+          <p:cNvCxnSpPr/>
+          <p:nvPr/>
+        </p:nvCxnSpPr>
+        <p:spPr>
+          <a:xfrm>
+            <a:off x="548640" y="2130552"/>
+            <a:ext cx="3566160" cy="0"/>
+          </a:xfrm>
+          <a:prstGeom prst="line">
+            <a:avLst/>
+          </a:prstGeom>
+          <a:ln w="12700">
+            <a:solidFill>
+              <a:srgbClr val="3D3C3C"/>
+            </a:solidFill>
+          </a:ln>
+        </p:spPr>
+        <p:style>
+          <a:lnRef idx="2">
+            <a:schemeClr val="accent1"/>
+          </a:lnRef>
+          <a:fillRef idx="0">
+            <a:schemeClr val="accent1"/>
+          </a:fillRef>
+          <a:effectRef idx="1">
+            <a:schemeClr val="accent1"/>
+          </a:effectRef>
+          <a:fontRef idx="minor">
+            <a:schemeClr val="tx1"/>
+          </a:fontRef>
+        </p:style>
+      </p:cxnSp>
+      <p:sp>
+        <p:nvSpPr>
+          <p:cNvPr id="36" name="TextBox 35"/>
+          <p:cNvSpPr txBox="1"/>
+          <p:nvPr/>
+        </p:nvSpPr>
+        <p:spPr>
+          <a:xfrm>
+            <a:off x="548640" y="2286000"/>
+            <a:ext cx="3566160" cy="868680"/>
+          </a:xfrm>
+          <a:prstGeom prst="rect">
+            <a:avLst/>
+          </a:prstGeom>
+          <a:noFill/>
+        </p:spPr>
+        <p:txBody>
+          <a:bodyPr wrap="square" lIns="0" rIns="0" tIns="0" bIns="0" anchor="t">
+            <a:spAutoFit/>
+          </a:bodyPr>
+          <a:lstStyle/>
+          <a:p>
+            <a:pPr algn="l"/>
+            <a:r>
+              <a:rPr sz="1250" b="1" i="0">
+                <a:solidFill>
+                  <a:srgbClr val="3D3C3C"/>
+                </a:solidFill>
+                <a:latin typeface="Poppins"/>
+              </a:rPr>
+              <a:t>Context before the solution</a:t>
+            </a:r>
+          </a:p>
+          <a:p>
+            <a:pPr algn="l"/>
+            <a:r>
+              <a:rPr sz="1150" b="0" i="0">
+                <a:solidFill>
+                  <a:srgbClr val="6E7178"/>
+                </a:solidFill>
+                <a:latin typeface="Poppins"/>
+              </a:rPr>
+              <a:t>Framing each idea around HSRA's needs made complex proposals easy to support.</a:t>
+            </a:r>
+          </a:p>
+        </p:txBody>
+      </p:sp>
+      <p:cxnSp>
+        <p:nvCxnSpPr>
+          <p:cNvPr id="37" name="Connector 36"/>
+          <p:cNvCxnSpPr/>
+          <p:nvPr/>
+        </p:nvCxnSpPr>
+        <p:spPr>
+          <a:xfrm>
+            <a:off x="548640" y="3136392"/>
+            <a:ext cx="3566160" cy="0"/>
+          </a:xfrm>
+          <a:prstGeom prst="line">
+            <a:avLst/>
+          </a:prstGeom>
+          <a:ln w="9525">
+            <a:solidFill>
+              <a:srgbClr val="D9DBE0"/>
+            </a:solidFill>
+          </a:ln>
+        </p:spPr>
+        <p:style>
+          <a:lnRef idx="2">
+            <a:schemeClr val="accent1"/>
+          </a:lnRef>
+          <a:fillRef idx="0">
+            <a:schemeClr val="accent1"/>
+          </a:fillRef>
+          <a:effectRef idx="1">
+            <a:schemeClr val="accent1"/>
+          </a:effectRef>
+          <a:fontRef idx="minor">
+            <a:schemeClr val="tx1"/>
+          </a:fontRef>
+        </p:style>
+      </p:cxnSp>
+      <p:sp>
+        <p:nvSpPr>
+          <p:cNvPr id="38" name="TextBox 37"/>
+          <p:cNvSpPr txBox="1"/>
+          <p:nvPr/>
+        </p:nvSpPr>
+        <p:spPr>
+          <a:xfrm>
+            <a:off x="548640" y="3246120"/>
+            <a:ext cx="3566160" cy="868680"/>
+          </a:xfrm>
+          <a:prstGeom prst="rect">
+            <a:avLst/>
+          </a:prstGeom>
+          <a:noFill/>
+        </p:spPr>
+        <p:txBody>
+          <a:bodyPr wrap="square" lIns="0" rIns="0" tIns="0" bIns="0" anchor="t">
+            <a:spAutoFit/>
+          </a:bodyPr>
+          <a:lstStyle/>
+          <a:p>
+            <a:pPr algn="l"/>
+            <a:r>
+              <a:rPr sz="1250" b="1" i="0">
+                <a:solidFill>
+                  <a:srgbClr val="3D3C3C"/>
+                </a:solidFill>
+                <a:latin typeface="Poppins"/>
+              </a:rPr>
+              <a:t>Clear, simple messages</a:t>
+            </a:r>
+          </a:p>
+          <a:p>
+            <a:pPr algn="l"/>
+            <a:r>
+              <a:rPr sz="1150" b="0" i="0">
+                <a:solidFill>
+                  <a:srgbClr val="6E7178"/>
+                </a:solidFill>
+                <a:latin typeface="Poppins"/>
+              </a:rPr>
+              <a:t>Distilling technical material into a few client-relevant points helped HSRA adopt our thinking.</a:t>
+            </a:r>
+          </a:p>
+        </p:txBody>
+      </p:sp>
+      <p:cxnSp>
+        <p:nvCxnSpPr>
+          <p:cNvPr id="39" name="Connector 38"/>
+          <p:cNvCxnSpPr/>
+          <p:nvPr/>
+        </p:nvCxnSpPr>
+        <p:spPr>
+          <a:xfrm>
+            <a:off x="548640" y="4096511"/>
+            <a:ext cx="3566160" cy="0"/>
+          </a:xfrm>
+          <a:prstGeom prst="line">
+            <a:avLst/>
+          </a:prstGeom>
+          <a:ln w="9525">
+            <a:solidFill>
+              <a:srgbClr val="D9DBE0"/>
+            </a:solidFill>
+          </a:ln>
+        </p:spPr>
+        <p:style>
+          <a:lnRef idx="2">
+            <a:schemeClr val="accent1"/>
+          </a:lnRef>
+          <a:fillRef idx="0">
+            <a:schemeClr val="accent1"/>
+          </a:fillRef>
+          <a:effectRef idx="1">
+            <a:schemeClr val="accent1"/>
+          </a:effectRef>
+          <a:fontRef idx="minor">
+            <a:schemeClr val="tx1"/>
+          </a:fontRef>
+        </p:style>
+      </p:cxnSp>
+      <p:sp>
+        <p:nvSpPr>
+          <p:cNvPr id="40" name="TextBox 39"/>
+          <p:cNvSpPr txBox="1"/>
+          <p:nvPr/>
+        </p:nvSpPr>
+        <p:spPr>
+          <a:xfrm>
+            <a:off x="548640" y="4206240"/>
+            <a:ext cx="3566160" cy="868680"/>
+          </a:xfrm>
+          <a:prstGeom prst="rect">
+            <a:avLst/>
+          </a:prstGeom>
+          <a:noFill/>
+        </p:spPr>
+        <p:txBody>
+          <a:bodyPr wrap="square" lIns="0" rIns="0" tIns="0" bIns="0" anchor="t">
+            <a:spAutoFit/>
+          </a:bodyPr>
+          <a:lstStyle/>
+          <a:p>
+            <a:pPr algn="l"/>
+            <a:r>
+              <a:rPr sz="1250" b="1" i="0">
+                <a:solidFill>
+                  <a:srgbClr val="3D3C3C"/>
+                </a:solidFill>
+                <a:latin typeface="Poppins"/>
+              </a:rPr>
+              <a:t>A strong presence</a:t>
+            </a:r>
+          </a:p>
+          <a:p>
+            <a:pPr algn="l"/>
+            <a:r>
+              <a:rPr sz="1150" b="0" i="0">
+                <a:solidFill>
+                  <a:srgbClr val="6E7178"/>
+                </a:solidFill>
+                <a:latin typeface="Poppins"/>
+              </a:rPr>
+              <a:t>Engaged, consistent body language made GoFar visibly the strongest ECI partner.</a:t>
+            </a:r>
+          </a:p>
+        </p:txBody>
+      </p:sp>
+      <p:sp>
+        <p:nvSpPr>
+          <p:cNvPr id="41" name="TextBox 40"/>
+          <p:cNvSpPr txBox="1"/>
+          <p:nvPr/>
+        </p:nvSpPr>
+        <p:spPr>
+          <a:xfrm>
+            <a:off x="4526280" y="1828800"/>
+            <a:ext cx="7114032" cy="256032"/>
+          </a:xfrm>
+          <a:prstGeom prst="rect">
+            <a:avLst/>
+          </a:prstGeom>
+          <a:noFill/>
+        </p:spPr>
+        <p:txBody>
+          <a:bodyPr wrap="square" lIns="0" rIns="0" tIns="0" bIns="0" anchor="t">
+            <a:spAutoFit/>
+          </a:bodyPr>
+          <a:lstStyle/>
+          <a:p>
+            <a:pPr algn="l"/>
+            <a:r>
+              <a:rPr sz="1050" b="1" i="0" spc="150">
+                <a:solidFill>
+                  <a:srgbClr val="F48047"/>
+                </a:solidFill>
+                <a:latin typeface="Poppins"/>
+              </a:rPr>
+              <a:t>WHAT NEEDS TO CHANGE BEFORE THE ECI</a:t>
+            </a:r>
+          </a:p>
+        </p:txBody>
+      </p:sp>
+      <p:cxnSp>
+        <p:nvCxnSpPr>
+          <p:cNvPr id="42" name="Connector 41"/>
+          <p:cNvCxnSpPr/>
+          <p:nvPr/>
+        </p:nvCxnSpPr>
+        <p:spPr>
+          <a:xfrm>
+            <a:off x="4526280" y="2130552"/>
+            <a:ext cx="7114032" cy="0"/>
+          </a:xfrm>
+          <a:prstGeom prst="line">
+            <a:avLst/>
+          </a:prstGeom>
+          <a:ln w="12700">
+            <a:solidFill>
+              <a:srgbClr val="3D3C3C"/>
+            </a:solidFill>
+          </a:ln>
+        </p:spPr>
+        <p:style>
+          <a:lnRef idx="2">
+            <a:schemeClr val="accent1"/>
+          </a:lnRef>
+          <a:fillRef idx="0">
+            <a:schemeClr val="accent1"/>
+          </a:fillRef>
+          <a:effectRef idx="1">
+            <a:schemeClr val="accent1"/>
+          </a:effectRef>
+          <a:fontRef idx="minor">
+            <a:schemeClr val="tx1"/>
+          </a:fontRef>
+        </p:style>
+      </p:cxnSp>
+      <p:sp>
+        <p:nvSpPr>
+          <p:cNvPr id="43" name="TextBox 42"/>
+          <p:cNvSpPr txBox="1"/>
+          <p:nvPr/>
+        </p:nvSpPr>
+        <p:spPr>
+          <a:xfrm>
+            <a:off x="4526280" y="2286000"/>
+            <a:ext cx="2011680" cy="777240"/>
+          </a:xfrm>
+          <a:prstGeom prst="rect">
+            <a:avLst/>
+          </a:prstGeom>
+          <a:noFill/>
+        </p:spPr>
+        <p:txBody>
+          <a:bodyPr wrap="square" lIns="0" rIns="0" tIns="0" bIns="0" anchor="t">
+            <a:spAutoFit/>
+          </a:bodyPr>
+          <a:lstStyle/>
+          <a:p>
+            <a:pPr algn="l"/>
+            <a:r>
+              <a:rPr sz="1250" b="1" i="0">
+                <a:solidFill>
+                  <a:srgbClr val="3D3C3C"/>
+                </a:solidFill>
+                <a:latin typeface="Poppins"/>
+              </a:rPr>
+              <a:t>A one-team culture</a:t>
+            </a:r>
+          </a:p>
+        </p:txBody>
+      </p:sp>
+      <p:sp>
+        <p:nvSpPr>
+          <p:cNvPr id="44" name="TextBox 43"/>
+          <p:cNvSpPr txBox="1"/>
+          <p:nvPr/>
+        </p:nvSpPr>
+        <p:spPr>
+          <a:xfrm>
+            <a:off x="6629400" y="2286000"/>
+            <a:ext cx="5010912" cy="777240"/>
+          </a:xfrm>
+          <a:prstGeom prst="rect">
+            <a:avLst/>
+          </a:prstGeom>
+          <a:noFill/>
+        </p:spPr>
+        <p:txBody>
+          <a:bodyPr wrap="square" lIns="0" rIns="0" tIns="0" bIns="0" anchor="t">
+            <a:spAutoFit/>
+          </a:bodyPr>
+          <a:lstStyle/>
+          <a:p>
+            <a:pPr algn="l"/>
+            <a:r>
+              <a:rPr sz="1150" b="0" i="0">
+                <a:solidFill>
+                  <a:srgbClr val="3D3C3C"/>
+                </a:solidFill>
+                <a:latin typeface="Poppins"/>
+              </a:rPr>
+              <a:t>The team works well together, but nothing yet ties the JV together as one team. The move to 100 Arthur Street is a great first step; a shared activity outside the office would help solidify that culture.</a:t>
+            </a:r>
+          </a:p>
+        </p:txBody>
+      </p:sp>
+      <p:cxnSp>
+        <p:nvCxnSpPr>
+          <p:cNvPr id="45" name="Connector 44"/>
+          <p:cNvCxnSpPr/>
+          <p:nvPr/>
+        </p:nvCxnSpPr>
+        <p:spPr>
+          <a:xfrm>
+            <a:off x="4526280" y="3063240"/>
+            <a:ext cx="7114032" cy="0"/>
+          </a:xfrm>
+          <a:prstGeom prst="line">
+            <a:avLst/>
+          </a:prstGeom>
+          <a:ln w="9525">
+            <a:solidFill>
+              <a:srgbClr val="D9DBE0"/>
+            </a:solidFill>
+          </a:ln>
+        </p:spPr>
+        <p:style>
+          <a:lnRef idx="2">
+            <a:schemeClr val="accent1"/>
+          </a:lnRef>
+          <a:fillRef idx="0">
+            <a:schemeClr val="accent1"/>
+          </a:fillRef>
+          <a:effectRef idx="1">
+            <a:schemeClr val="accent1"/>
+          </a:effectRef>
+          <a:fontRef idx="minor">
+            <a:schemeClr val="tx1"/>
+          </a:fontRef>
+        </p:style>
+      </p:cxnSp>
+      <p:sp>
+        <p:nvSpPr>
+          <p:cNvPr id="46" name="TextBox 45"/>
+          <p:cNvSpPr txBox="1"/>
+          <p:nvPr/>
+        </p:nvSpPr>
+        <p:spPr>
+          <a:xfrm>
+            <a:off x="4526280" y="3154680"/>
+            <a:ext cx="2011680" cy="777240"/>
+          </a:xfrm>
+          <a:prstGeom prst="rect">
+            <a:avLst/>
+          </a:prstGeom>
+          <a:noFill/>
+        </p:spPr>
+        <p:txBody>
+          <a:bodyPr wrap="square" lIns="0" rIns="0" tIns="0" bIns="0" anchor="t">
+            <a:spAutoFit/>
+          </a:bodyPr>
+          <a:lstStyle/>
+          <a:p>
+            <a:pPr algn="l"/>
+            <a:r>
+              <a:rPr sz="1250" b="1" i="0">
+                <a:solidFill>
+                  <a:srgbClr val="3D3C3C"/>
+                </a:solidFill>
+                <a:latin typeface="Poppins"/>
+              </a:rPr>
+              <a:t>Front-loaded preparation</a:t>
+            </a:r>
+          </a:p>
+        </p:txBody>
+      </p:sp>
+      <p:sp>
+        <p:nvSpPr>
+          <p:cNvPr id="47" name="TextBox 46"/>
+          <p:cNvSpPr txBox="1"/>
+          <p:nvPr/>
+        </p:nvSpPr>
+        <p:spPr>
+          <a:xfrm>
+            <a:off x="6629400" y="3154680"/>
+            <a:ext cx="5010912" cy="777240"/>
+          </a:xfrm>
+          <a:prstGeom prst="rect">
+            <a:avLst/>
+          </a:prstGeom>
+          <a:noFill/>
+        </p:spPr>
+        <p:txBody>
+          <a:bodyPr wrap="square" lIns="0" rIns="0" tIns="0" bIns="0" anchor="t">
+            <a:spAutoFit/>
+          </a:bodyPr>
+          <a:lstStyle/>
+          <a:p>
+            <a:pPr algn="l"/>
+            <a:r>
+              <a:rPr sz="1150" b="0" i="0">
+                <a:solidFill>
+                  <a:srgbClr val="3D3C3C"/>
+                </a:solidFill>
+                <a:latin typeface="Poppins"/>
+              </a:rPr>
+              <a:t>Day-before prep sessions leave little room to change anything and lead to late nights. In our approach, content is locked two days out, leaving the final two days for rehearsal and minor tweaks. This should be the ECI standard.</a:t>
+            </a:r>
+          </a:p>
+        </p:txBody>
+      </p:sp>
+      <p:cxnSp>
+        <p:nvCxnSpPr>
+          <p:cNvPr id="48" name="Connector 47"/>
+          <p:cNvCxnSpPr/>
+          <p:nvPr/>
+        </p:nvCxnSpPr>
+        <p:spPr>
+          <a:xfrm>
+            <a:off x="4526280" y="4023360"/>
+            <a:ext cx="7114032" cy="0"/>
+          </a:xfrm>
+          <a:prstGeom prst="line">
+            <a:avLst/>
+          </a:prstGeom>
+          <a:ln w="9525">
+            <a:solidFill>
+              <a:srgbClr val="D9DBE0"/>
+            </a:solidFill>
+          </a:ln>
+        </p:spPr>
+        <p:style>
+          <a:lnRef idx="2">
+            <a:schemeClr val="accent1"/>
+          </a:lnRef>
+          <a:fillRef idx="0">
+            <a:schemeClr val="accent1"/>
+          </a:fillRef>
+          <a:effectRef idx="1">
+            <a:schemeClr val="accent1"/>
+          </a:effectRef>
+          <a:fontRef idx="minor">
+            <a:schemeClr val="tx1"/>
+          </a:fontRef>
+        </p:style>
+      </p:cxnSp>
+      <p:sp>
+        <p:nvSpPr>
+          <p:cNvPr id="49" name="TextBox 48"/>
+          <p:cNvSpPr txBox="1"/>
+          <p:nvPr/>
+        </p:nvSpPr>
+        <p:spPr>
+          <a:xfrm>
+            <a:off x="4526280" y="4114800"/>
+            <a:ext cx="2011680" cy="548640"/>
+          </a:xfrm>
+          <a:prstGeom prst="rect">
+            <a:avLst/>
+          </a:prstGeom>
+          <a:noFill/>
+        </p:spPr>
+        <p:txBody>
+          <a:bodyPr wrap="square" lIns="0" rIns="0" tIns="0" bIns="0" anchor="t">
+            <a:spAutoFit/>
+          </a:bodyPr>
+          <a:lstStyle/>
+          <a:p>
+            <a:pPr algn="l"/>
+            <a:r>
+              <a:rPr sz="1250" b="1" i="0">
+                <a:solidFill>
+                  <a:srgbClr val="3D3C3C"/>
+                </a:solidFill>
+                <a:latin typeface="Poppins"/>
+              </a:rPr>
+              <a:t>One agreed position</a:t>
+            </a:r>
+          </a:p>
+        </p:txBody>
+      </p:sp>
+      <p:sp>
+        <p:nvSpPr>
+          <p:cNvPr id="50" name="TextBox 49"/>
+          <p:cNvSpPr txBox="1"/>
+          <p:nvPr/>
+        </p:nvSpPr>
+        <p:spPr>
+          <a:xfrm>
+            <a:off x="6629400" y="4114800"/>
+            <a:ext cx="5010912" cy="548640"/>
+          </a:xfrm>
+          <a:prstGeom prst="rect">
+            <a:avLst/>
+          </a:prstGeom>
+          <a:noFill/>
+        </p:spPr>
+        <p:txBody>
+          <a:bodyPr wrap="square" lIns="0" rIns="0" tIns="0" bIns="0" anchor="t">
+            <a:spAutoFit/>
+          </a:bodyPr>
+          <a:lstStyle/>
+          <a:p>
+            <a:pPr algn="l"/>
+            <a:r>
+              <a:rPr sz="1150" b="0" i="0">
+                <a:solidFill>
+                  <a:srgbClr val="3D3C3C"/>
+                </a:solidFill>
+                <a:latin typeface="Poppins"/>
+              </a:rPr>
+              <a:t>Share a weekly update on the latest design position, and raise concerns early rather than defaulting to yes.</a:t>
+            </a:r>
+          </a:p>
+        </p:txBody>
+      </p:sp>
+      <p:cxnSp>
+        <p:nvCxnSpPr>
+          <p:cNvPr id="51" name="Connector 50"/>
+          <p:cNvCxnSpPr/>
+          <p:nvPr/>
+        </p:nvCxnSpPr>
+        <p:spPr>
+          <a:xfrm>
+            <a:off x="4526280" y="4590288"/>
+            <a:ext cx="7114032" cy="0"/>
+          </a:xfrm>
+          <a:prstGeom prst="line">
+            <a:avLst/>
+          </a:prstGeom>
+          <a:ln w="9525">
+            <a:solidFill>
+              <a:srgbClr val="D9DBE0"/>
+            </a:solidFill>
+          </a:ln>
+        </p:spPr>
+        <p:style>
+          <a:lnRef idx="2">
+            <a:schemeClr val="accent1"/>
+          </a:lnRef>
+          <a:fillRef idx="0">
+            <a:schemeClr val="accent1"/>
+          </a:fillRef>
+          <a:effectRef idx="1">
+            <a:schemeClr val="accent1"/>
+          </a:effectRef>
+          <a:fontRef idx="minor">
+            <a:schemeClr val="tx1"/>
+          </a:fontRef>
+        </p:style>
+      </p:cxnSp>
+      <p:sp>
+        <p:nvSpPr>
+          <p:cNvPr id="52" name="TextBox 51"/>
+          <p:cNvSpPr txBox="1"/>
+          <p:nvPr/>
+        </p:nvSpPr>
+        <p:spPr>
+          <a:xfrm>
+            <a:off x="4526280" y="4681728"/>
+            <a:ext cx="2011680" cy="548640"/>
+          </a:xfrm>
+          <a:prstGeom prst="rect">
+            <a:avLst/>
+          </a:prstGeom>
+          <a:noFill/>
+        </p:spPr>
+        <p:txBody>
+          <a:bodyPr wrap="square" lIns="0" rIns="0" tIns="0" bIns="0" anchor="t">
+            <a:spAutoFit/>
+          </a:bodyPr>
+          <a:lstStyle/>
+          <a:p>
+            <a:pPr algn="l"/>
+            <a:r>
+              <a:rPr sz="1250" b="1" i="0">
+                <a:solidFill>
+                  <a:srgbClr val="3D3C3C"/>
+                </a:solidFill>
+                <a:latin typeface="Poppins"/>
+              </a:rPr>
+              <a:t>Focus and continuity</a:t>
+            </a:r>
+          </a:p>
+        </p:txBody>
+      </p:sp>
+      <p:sp>
+        <p:nvSpPr>
+          <p:cNvPr id="53" name="TextBox 52"/>
+          <p:cNvSpPr txBox="1"/>
+          <p:nvPr/>
+        </p:nvSpPr>
+        <p:spPr>
+          <a:xfrm>
+            <a:off x="6629400" y="4681728"/>
+            <a:ext cx="5010912" cy="548640"/>
+          </a:xfrm>
+          <a:prstGeom prst="rect">
+            <a:avLst/>
+          </a:prstGeom>
+          <a:noFill/>
+        </p:spPr>
+        <p:txBody>
+          <a:bodyPr wrap="square" lIns="0" rIns="0" tIns="0" bIns="0" anchor="t">
+            <a:spAutoFit/>
+          </a:bodyPr>
+          <a:lstStyle/>
+          <a:p>
+            <a:pPr algn="l"/>
+            <a:r>
+              <a:rPr sz="1150" b="0" i="0">
+                <a:solidFill>
+                  <a:srgbClr val="3D3C3C"/>
+                </a:solidFill>
+                <a:latin typeface="Poppins"/>
+              </a:rPr>
+              <a:t>Track HSRA's requests in one place, keep consistent faces across sessions, and present a few focused slides with detail in reserve.</a:t>
+            </a:r>
+          </a:p>
+        </p:txBody>
+      </p:sp>
+      <p:cxnSp>
+        <p:nvCxnSpPr>
+          <p:cNvPr id="54" name="Connector 53"/>
+          <p:cNvCxnSpPr/>
+          <p:nvPr/>
+        </p:nvCxnSpPr>
+        <p:spPr>
+          <a:xfrm>
+            <a:off x="548640" y="5413248"/>
+            <a:ext cx="11091672" cy="0"/>
+          </a:xfrm>
+          <a:prstGeom prst="line">
+            <a:avLst/>
+          </a:prstGeom>
+          <a:ln w="12700">
+            <a:solidFill>
+              <a:srgbClr val="3D3C3C"/>
+            </a:solidFill>
+          </a:ln>
+        </p:spPr>
+        <p:style>
+          <a:lnRef idx="2">
+            <a:schemeClr val="accent1"/>
+          </a:lnRef>
+          <a:fillRef idx="0">
+            <a:schemeClr val="accent1"/>
+          </a:fillRef>
+          <a:effectRef idx="1">
+            <a:schemeClr val="accent1"/>
+          </a:effectRef>
+          <a:fontRef idx="minor">
+            <a:schemeClr val="tx1"/>
+          </a:fontRef>
+        </p:style>
+      </p:cxnSp>
+      <p:sp>
+        <p:nvSpPr>
+          <p:cNvPr id="55" name="TextBox 54"/>
+          <p:cNvSpPr txBox="1"/>
+          <p:nvPr/>
+        </p:nvSpPr>
+        <p:spPr>
+          <a:xfrm>
+            <a:off x="548640" y="5532120"/>
+            <a:ext cx="11091672" cy="365760"/>
+          </a:xfrm>
+          <a:prstGeom prst="rect">
+            <a:avLst/>
+          </a:prstGeom>
+          <a:noFill/>
+        </p:spPr>
+        <p:txBody>
+          <a:bodyPr wrap="square" lIns="0" rIns="0" tIns="0" bIns="0" anchor="t">
+            <a:spAutoFit/>
+          </a:bodyPr>
+          <a:lstStyle/>
+          <a:p>
+            <a:pPr algn="l"/>
+            <a:r>
+              <a:rPr sz="1300" b="1" i="0">
+                <a:solidFill>
+                  <a:srgbClr val="F48047"/>
+                </a:solidFill>
+                <a:latin typeface="Poppins"/>
+              </a:rPr>
+              <a:t>For discussion:  </a:t>
+            </a:r>
+            <a:r>
+              <a:rPr sz="1300" b="1" i="0">
+                <a:solidFill>
+                  <a:srgbClr val="3D3C3C"/>
+                </a:solidFill>
+                <a:latin typeface="Poppins"/>
+              </a:rPr>
+              <a:t>What else have you seen that we should address before the ECI Phase?</a:t>
+            </a:r>
+          </a:p>
+        </p:txBody>
+      </p:sp>
+    </p:spTree>
+  </p:cSld>
+  <p:clrMapOvr>
+    <a:masterClrMapping/>
+  </p:clrMapOvr>
+</p:sld>
+</file>
+
+<file path=ppt/slides/slide8.xml><?xml version="1.0" encoding="utf-8"?>
+<p:sld xmlns:a="http://schemas.openxmlformats.org/drawingml/2006/main" xmlns:r="http://schemas.openxmlformats.org/officeDocument/2006/relationships" xmlns:p="http://schemas.openxmlformats.org/presentationml/2006/main">
+  <p:cSld>
+    <p:spTree>
+      <p:nvGrpSpPr>
+        <p:cNvPr id="1" name=""/>
+        <p:cNvGrpSpPr/>
+        <p:nvPr/>
+      </p:nvGrpSpPr>
+      <p:grpSpPr>
+        <a:xfrm>
+          <a:off x="0" y="0"/>
+          <a:ext cx="0" cy="0"/>
+          <a:chOff x="0" y="0"/>
+          <a:chExt cx="0" cy="0"/>
+        </a:xfrm>
+      </p:grpSpPr>
+      <p:sp>
+        <p:nvSpPr>
+          <p:cNvPr id="3" name="Text 0"/>
+          <p:cNvSpPr>
+            <a:spLocks noGrp="1"/>
+          </p:cNvSpPr>
+          <p:nvPr>
+            <p:ph type="title" idx="101" hasCustomPrompt="1"/>
+          </p:nvPr>
+        </p:nvSpPr>
+        <p:spPr>
+          <a:xfrm>
+            <a:off x="548640" y="658368"/>
+            <a:ext cx="11094415" cy="640080"/>
+          </a:xfrm>
+          <a:prstGeom prst="rect">
+            <a:avLst/>
+          </a:prstGeom>
+          <a:noFill/>
+          <a:ln/>
+        </p:spPr>
+        <p:txBody>
+          <a:bodyPr wrap="square" lIns="0" tIns="0" rIns="0" bIns="0" rtlCol="0" anchor="t"/>
+          <a:lstStyle/>
+          <a:p>
+            <a:pPr marL="0" indent="0" algn="l">
+              <a:buNone/>
+            </a:pPr>
+            <a:r>
               <a:rPr lang="en-US" sz="2800" b="1" dirty="0">
                 <a:solidFill>
                   <a:schemeClr val="tx1"/>
@@ -25944,7 +27927,7 @@
 </p:sld>
 </file>
 
-<file path=ppt/slides/slide7.xml><?xml version="1.0" encoding="utf-8"?>
+<file path=ppt/slides/slide9.xml><?xml version="1.0" encoding="utf-8"?>
 <p:sld xmlns:a="http://schemas.openxmlformats.org/drawingml/2006/main" xmlns:r="http://schemas.openxmlformats.org/officeDocument/2006/relationships" xmlns:p="http://schemas.openxmlformats.org/presentationml/2006/main">
   <p:cSld>
     <p:spTree>
@@ -28609,1988 +30592,6 @@
                 <a:cs typeface="Poppins Medium" panose="00000600000000000000" pitchFamily="2" charset="0"/>
               </a:rPr>
               <a:t>8</a:t>
-            </a:r>
-          </a:p>
-        </p:txBody>
-      </p:sp>
-    </p:spTree>
-  </p:cSld>
-  <p:clrMapOvr>
-    <a:masterClrMapping/>
-  </p:clrMapOvr>
-</p:sld>
-</file>
-
-<file path=ppt/slides/slide8.xml><?xml version="1.0" encoding="utf-8"?>
-<p:sld xmlns:a="http://schemas.openxmlformats.org/drawingml/2006/main" xmlns:r="http://schemas.openxmlformats.org/officeDocument/2006/relationships" xmlns:p="http://schemas.openxmlformats.org/presentationml/2006/main">
-  <p:cSld>
-    <p:spTree>
-      <p:nvGrpSpPr>
-        <p:cNvPr id="1" name=""/>
-        <p:cNvGrpSpPr/>
-        <p:nvPr/>
-      </p:nvGrpSpPr>
-      <p:grpSpPr>
-        <a:xfrm>
-          <a:off x="0" y="0"/>
-          <a:ext cx="0" cy="0"/>
-          <a:chOff x="0" y="0"/>
-          <a:chExt cx="0" cy="0"/>
-        </a:xfrm>
-      </p:grpSpPr>
-      <p:sp>
-        <p:nvSpPr>
-          <p:cNvPr id="3" name="Text 0"/>
-          <p:cNvSpPr>
-            <a:spLocks noGrp="1"/>
-          </p:cNvSpPr>
-          <p:nvPr>
-            <p:ph type="title" idx="101" hasCustomPrompt="1"/>
-          </p:nvPr>
-        </p:nvSpPr>
-        <p:spPr>
-          <a:xfrm>
-            <a:off x="548640" y="658368"/>
-            <a:ext cx="11094415" cy="640080"/>
-          </a:xfrm>
-          <a:prstGeom prst="rect">
-            <a:avLst/>
-          </a:prstGeom>
-          <a:noFill/>
-          <a:ln/>
-        </p:spPr>
-        <p:txBody>
-          <a:bodyPr wrap="square" lIns="0" tIns="0" rIns="0" bIns="0" rtlCol="0" anchor="t"/>
-          <a:lstStyle/>
-          <a:p>
-            <a:pPr marL="0" indent="0" algn="l">
-              <a:buNone/>
-            </a:pPr>
-            <a:r>
-              <a:rPr lang="en-US" dirty="0"/>
-              <a:t>Four lessons from the C&amp;V Phase</a:t>
-            </a:r>
-            <a:endParaRPr lang="en-US" sz="2800" dirty="0"/>
-          </a:p>
-        </p:txBody>
-      </p:sp>
-      <p:sp>
-        <p:nvSpPr>
-          <p:cNvPr id="25" name="Slide Number Placeholder 0"/>
-          <p:cNvSpPr>
-            <a:spLocks noGrp="1"/>
-          </p:cNvSpPr>
-          <p:nvPr>
-            <p:ph type="sldNum" sz="quarter" idx="4294967295"/>
-          </p:nvPr>
-        </p:nvSpPr>
-        <p:spPr>
-          <a:xfrm>
-            <a:off x="11256264" y="6327648"/>
-            <a:ext cx="384048" cy="274320"/>
-          </a:xfrm>
-          <a:prstGeom prst="rect">
-            <a:avLst/>
-          </a:prstGeom>
-          <a:extLst>
-            <a:ext uri="{C572A759-6A51-4108-AA02-DFA0A04FC94B}">
-              <ma14:wrappingTextBoxFlag xmlns:ma14="http://schemas.microsoft.com/office/mac/drawingml/2011/main" xmlns="" val="0"/>
-            </a:ext>
-          </a:extLst>
-        </p:spPr>
-        <p:txBody>
-          <a:bodyPr lIns="0" tIns="0" rIns="0" bIns="0" anchor="ctr"/>
-          <a:lstStyle>
-            <a:lvl1pPr>
-              <a:defRPr sz="1000">
-                <a:solidFill>
-                  <a:srgbClr val="FFFFFF"/>
-                </a:solidFill>
-              </a:defRPr>
-            </a:lvl1pPr>
-          </a:lstStyle>
-          <a:p>
-            <a:pPr marL="0" marR="0" lvl="0" indent="0" algn="ctr" defTabSz="914400" rtl="0" eaLnBrk="1" fontAlgn="auto" latinLnBrk="0" hangingPunct="1">
-              <a:lnSpc>
-                <a:spcPct val="100000"/>
-              </a:lnSpc>
-              <a:spcBef>
-                <a:spcPts val="0"/>
-              </a:spcBef>
-              <a:spcAft>
-                <a:spcPts val="0"/>
-              </a:spcAft>
-              <a:buClrTx/>
-              <a:buSzTx/>
-              <a:buFontTx/>
-              <a:buNone/>
-              <a:tabLst/>
-              <a:defRPr/>
-            </a:pPr>
-            <a:fld id="{F7021451-1387-4CA6-816F-3879F97B5CBC}" type="slidenum">
-              <a:rPr kumimoji="0" lang="en-US" sz="1000" b="0" i="0" u="none" strike="noStrike" kern="1200" cap="none" spc="0" normalizeH="0" baseline="0" noProof="0">
-                <a:ln>
-                  <a:noFill/>
-                </a:ln>
-                <a:solidFill>
-                  <a:srgbClr val="FFFFFF"/>
-                </a:solidFill>
-                <a:effectLst/>
-                <a:uLnTx/>
-                <a:uFillTx/>
-                <a:latin typeface="Poppins"/>
-                <a:ea typeface="+mn-ea"/>
-                <a:cs typeface="+mn-cs"/>
-              </a:rPr>
-              <a:pPr marL="0" marR="0" lvl="0" indent="0" algn="ctr" defTabSz="914400" rtl="0" eaLnBrk="1" fontAlgn="auto" latinLnBrk="0" hangingPunct="1">
-                <a:lnSpc>
-                  <a:spcPct val="100000"/>
-                </a:lnSpc>
-                <a:spcBef>
-                  <a:spcPts val="0"/>
-                </a:spcBef>
-                <a:spcAft>
-                  <a:spcPts val="0"/>
-                </a:spcAft>
-                <a:buClrTx/>
-                <a:buSzTx/>
-                <a:buFontTx/>
-                <a:buNone/>
-                <a:tabLst/>
-                <a:defRPr/>
-              </a:pPr>
-              <a:t>8</a:t>
-            </a:fld>
-            <a:endParaRPr kumimoji="0" lang="en-US" sz="1000" b="0" i="0" u="none" strike="noStrike" kern="1200" cap="none" spc="0" normalizeH="0" baseline="0" noProof="0">
-              <a:ln>
-                <a:noFill/>
-              </a:ln>
-              <a:solidFill>
-                <a:srgbClr val="FFFFFF"/>
-              </a:solidFill>
-              <a:effectLst/>
-              <a:uLnTx/>
-              <a:uFillTx/>
-              <a:latin typeface="Poppins"/>
-              <a:ea typeface="+mn-ea"/>
-              <a:cs typeface="+mn-cs"/>
-            </a:endParaRPr>
-          </a:p>
-        </p:txBody>
-      </p:sp>
-      <p:sp>
-        <p:nvSpPr>
-          <p:cNvPr id="26" name="TextBox 25"/>
-          <p:cNvSpPr txBox="1"/>
-          <p:nvPr/>
-        </p:nvSpPr>
-        <p:spPr>
-          <a:xfrm>
-            <a:off x="1417320" y="1481328"/>
-            <a:ext cx="3108960" cy="256032"/>
-          </a:xfrm>
-          <a:prstGeom prst="rect">
-            <a:avLst/>
-          </a:prstGeom>
-          <a:noFill/>
-        </p:spPr>
-        <p:txBody>
-          <a:bodyPr wrap="square" lIns="0" rIns="0" tIns="0" bIns="0" anchor="t">
-            <a:spAutoFit/>
-          </a:bodyPr>
-          <a:lstStyle/>
-          <a:p>
-            <a:pPr algn="l"/>
-            <a:r>
-              <a:rPr sz="1050" b="1" i="0" spc="150">
-                <a:solidFill>
-                  <a:srgbClr val="6E7178"/>
-                </a:solidFill>
-                <a:latin typeface="Poppins"/>
-              </a:rPr>
-              <a:t>LESSON</a:t>
-            </a:r>
-          </a:p>
-        </p:txBody>
-      </p:sp>
-      <p:sp>
-        <p:nvSpPr>
-          <p:cNvPr id="27" name="TextBox 26"/>
-          <p:cNvSpPr txBox="1"/>
-          <p:nvPr/>
-        </p:nvSpPr>
-        <p:spPr>
-          <a:xfrm>
-            <a:off x="4709160" y="1481328"/>
-            <a:ext cx="3383280" cy="256032"/>
-          </a:xfrm>
-          <a:prstGeom prst="rect">
-            <a:avLst/>
-          </a:prstGeom>
-          <a:noFill/>
-        </p:spPr>
-        <p:txBody>
-          <a:bodyPr wrap="square" lIns="0" rIns="0" tIns="0" bIns="0" anchor="t">
-            <a:spAutoFit/>
-          </a:bodyPr>
-          <a:lstStyle/>
-          <a:p>
-            <a:pPr algn="l"/>
-            <a:r>
-              <a:rPr sz="1050" b="1" i="0" spc="150">
-                <a:solidFill>
-                  <a:srgbClr val="6E7178"/>
-                </a:solidFill>
-                <a:latin typeface="Poppins"/>
-              </a:rPr>
-              <a:t>WHAT IT MEANS</a:t>
-            </a:r>
-          </a:p>
-        </p:txBody>
-      </p:sp>
-      <p:sp>
-        <p:nvSpPr>
-          <p:cNvPr id="28" name="TextBox 27"/>
-          <p:cNvSpPr txBox="1"/>
-          <p:nvPr/>
-        </p:nvSpPr>
-        <p:spPr>
-          <a:xfrm>
-            <a:off x="8366760" y="1481328"/>
-            <a:ext cx="3273552" cy="256032"/>
-          </a:xfrm>
-          <a:prstGeom prst="rect">
-            <a:avLst/>
-          </a:prstGeom>
-          <a:noFill/>
-        </p:spPr>
-        <p:txBody>
-          <a:bodyPr wrap="square" lIns="0" rIns="0" tIns="0" bIns="0" anchor="t">
-            <a:spAutoFit/>
-          </a:bodyPr>
-          <a:lstStyle/>
-          <a:p>
-            <a:pPr algn="l"/>
-            <a:r>
-              <a:rPr sz="1050" b="1" i="0" spc="150">
-                <a:solidFill>
-                  <a:srgbClr val="6E7178"/>
-                </a:solidFill>
-                <a:latin typeface="Poppins"/>
-              </a:rPr>
-              <a:t>IN PRACTICE</a:t>
-            </a:r>
-          </a:p>
-        </p:txBody>
-      </p:sp>
-      <p:cxnSp>
-        <p:nvCxnSpPr>
-          <p:cNvPr id="29" name="Connector 28"/>
-          <p:cNvCxnSpPr/>
-          <p:nvPr/>
-        </p:nvCxnSpPr>
-        <p:spPr>
-          <a:xfrm>
-            <a:off x="548640" y="1801368"/>
-            <a:ext cx="11091672" cy="0"/>
-          </a:xfrm>
-          <a:prstGeom prst="line">
-            <a:avLst/>
-          </a:prstGeom>
-          <a:ln w="12700">
-            <a:solidFill>
-              <a:srgbClr val="3D3C3C"/>
-            </a:solidFill>
-          </a:ln>
-        </p:spPr>
-        <p:style>
-          <a:lnRef idx="2">
-            <a:schemeClr val="accent1"/>
-          </a:lnRef>
-          <a:fillRef idx="0">
-            <a:schemeClr val="accent1"/>
-          </a:fillRef>
-          <a:effectRef idx="1">
-            <a:schemeClr val="accent1"/>
-          </a:effectRef>
-          <a:fontRef idx="minor">
-            <a:schemeClr val="tx1"/>
-          </a:fontRef>
-        </p:style>
-      </p:cxnSp>
-      <p:sp>
-        <p:nvSpPr>
-          <p:cNvPr id="30" name="TextBox 29"/>
-          <p:cNvSpPr txBox="1"/>
-          <p:nvPr/>
-        </p:nvSpPr>
-        <p:spPr>
-          <a:xfrm>
-            <a:off x="548640" y="1892808"/>
-            <a:ext cx="777240" cy="548640"/>
-          </a:xfrm>
-          <a:prstGeom prst="rect">
-            <a:avLst/>
-          </a:prstGeom>
-          <a:noFill/>
-        </p:spPr>
-        <p:txBody>
-          <a:bodyPr wrap="square" lIns="0" rIns="0" tIns="0" bIns="0" anchor="t">
-            <a:spAutoFit/>
-          </a:bodyPr>
-          <a:lstStyle/>
-          <a:p>
-            <a:pPr algn="l"/>
-            <a:r>
-              <a:rPr sz="3000" b="1" i="0">
-                <a:solidFill>
-                  <a:srgbClr val="F48047"/>
-                </a:solidFill>
-                <a:latin typeface="Poppins"/>
-              </a:rPr>
-              <a:t>01</a:t>
-            </a:r>
-          </a:p>
-        </p:txBody>
-      </p:sp>
-      <p:sp>
-        <p:nvSpPr>
-          <p:cNvPr id="31" name="TextBox 30"/>
-          <p:cNvSpPr txBox="1"/>
-          <p:nvPr/>
-        </p:nvSpPr>
-        <p:spPr>
-          <a:xfrm>
-            <a:off x="1417320" y="1938528"/>
-            <a:ext cx="3108960" cy="822960"/>
-          </a:xfrm>
-          <a:prstGeom prst="rect">
-            <a:avLst/>
-          </a:prstGeom>
-          <a:noFill/>
-        </p:spPr>
-        <p:txBody>
-          <a:bodyPr wrap="square" lIns="0" rIns="0" tIns="0" bIns="0" anchor="t">
-            <a:spAutoFit/>
-          </a:bodyPr>
-          <a:lstStyle/>
-          <a:p>
-            <a:pPr algn="l"/>
-            <a:r>
-              <a:rPr sz="1500" b="1" i="0">
-                <a:solidFill>
-                  <a:srgbClr val="3D3C3C"/>
-                </a:solidFill>
-                <a:latin typeface="Poppins"/>
-              </a:rPr>
-              <a:t>Preparation is paramount</a:t>
-            </a:r>
-          </a:p>
-        </p:txBody>
-      </p:sp>
-      <p:sp>
-        <p:nvSpPr>
-          <p:cNvPr id="32" name="TextBox 31"/>
-          <p:cNvSpPr txBox="1"/>
-          <p:nvPr/>
-        </p:nvSpPr>
-        <p:spPr>
-          <a:xfrm>
-            <a:off x="4709160" y="1938528"/>
-            <a:ext cx="3383280" cy="868680"/>
-          </a:xfrm>
-          <a:prstGeom prst="rect">
-            <a:avLst/>
-          </a:prstGeom>
-          <a:noFill/>
-        </p:spPr>
-        <p:txBody>
-          <a:bodyPr wrap="square" lIns="0" rIns="0" tIns="0" bIns="0" anchor="t">
-            <a:spAutoFit/>
-          </a:bodyPr>
-          <a:lstStyle/>
-          <a:p>
-            <a:pPr algn="l"/>
-            <a:r>
-              <a:rPr sz="1150" b="0" i="0">
-                <a:solidFill>
-                  <a:srgbClr val="3D3C3C"/>
-                </a:solidFill>
-                <a:latin typeface="Poppins"/>
-              </a:rPr>
-              <a:t>Thorough preparation gives the team its key messages and puts GoFar in a strong light, even when slides are not presented.</a:t>
-            </a:r>
-          </a:p>
-        </p:txBody>
-      </p:sp>
-      <p:sp>
-        <p:nvSpPr>
-          <p:cNvPr id="33" name="TextBox 32"/>
-          <p:cNvSpPr txBox="1"/>
-          <p:nvPr/>
-        </p:nvSpPr>
-        <p:spPr>
-          <a:xfrm>
-            <a:off x="8366760" y="1938528"/>
-            <a:ext cx="3273552" cy="868680"/>
-          </a:xfrm>
-          <a:prstGeom prst="rect">
-            <a:avLst/>
-          </a:prstGeom>
-          <a:noFill/>
-        </p:spPr>
-        <p:txBody>
-          <a:bodyPr wrap="square" lIns="0" rIns="0" tIns="0" bIns="0" anchor="t">
-            <a:spAutoFit/>
-          </a:bodyPr>
-          <a:lstStyle/>
-          <a:p>
-            <a:pPr algn="l"/>
-            <a:r>
-              <a:rPr sz="1100" b="0" i="1">
-                <a:solidFill>
-                  <a:srgbClr val="6E7178"/>
-                </a:solidFill>
-                <a:latin typeface="Poppins"/>
-              </a:rPr>
-              <a:t>In instances where GoFar doesn't present, the team is still better informed and ready because of the work done beforehand.</a:t>
-            </a:r>
-          </a:p>
-        </p:txBody>
-      </p:sp>
-      <p:cxnSp>
-        <p:nvCxnSpPr>
-          <p:cNvPr id="34" name="Connector 33"/>
-          <p:cNvCxnSpPr/>
-          <p:nvPr/>
-        </p:nvCxnSpPr>
-        <p:spPr>
-          <a:xfrm>
-            <a:off x="548640" y="2926080"/>
-            <a:ext cx="11091672" cy="0"/>
-          </a:xfrm>
-          <a:prstGeom prst="line">
-            <a:avLst/>
-          </a:prstGeom>
-          <a:ln w="9525">
-            <a:solidFill>
-              <a:srgbClr val="D9DBE0"/>
-            </a:solidFill>
-          </a:ln>
-        </p:spPr>
-        <p:style>
-          <a:lnRef idx="2">
-            <a:schemeClr val="accent1"/>
-          </a:lnRef>
-          <a:fillRef idx="0">
-            <a:schemeClr val="accent1"/>
-          </a:fillRef>
-          <a:effectRef idx="1">
-            <a:schemeClr val="accent1"/>
-          </a:effectRef>
-          <a:fontRef idx="minor">
-            <a:schemeClr val="tx1"/>
-          </a:fontRef>
-        </p:style>
-      </p:cxnSp>
-      <p:sp>
-        <p:nvSpPr>
-          <p:cNvPr id="35" name="TextBox 34"/>
-          <p:cNvSpPr txBox="1"/>
-          <p:nvPr/>
-        </p:nvSpPr>
-        <p:spPr>
-          <a:xfrm>
-            <a:off x="548640" y="2990088"/>
-            <a:ext cx="777240" cy="548640"/>
-          </a:xfrm>
-          <a:prstGeom prst="rect">
-            <a:avLst/>
-          </a:prstGeom>
-          <a:noFill/>
-        </p:spPr>
-        <p:txBody>
-          <a:bodyPr wrap="square" lIns="0" rIns="0" tIns="0" bIns="0" anchor="t">
-            <a:spAutoFit/>
-          </a:bodyPr>
-          <a:lstStyle/>
-          <a:p>
-            <a:pPr algn="l"/>
-            <a:r>
-              <a:rPr sz="3000" b="1" i="0">
-                <a:solidFill>
-                  <a:srgbClr val="0E98D7"/>
-                </a:solidFill>
-                <a:latin typeface="Poppins"/>
-              </a:rPr>
-              <a:t>02</a:t>
-            </a:r>
-          </a:p>
-        </p:txBody>
-      </p:sp>
-      <p:sp>
-        <p:nvSpPr>
-          <p:cNvPr id="36" name="TextBox 35"/>
-          <p:cNvSpPr txBox="1"/>
-          <p:nvPr/>
-        </p:nvSpPr>
-        <p:spPr>
-          <a:xfrm>
-            <a:off x="1417320" y="3035808"/>
-            <a:ext cx="3108960" cy="822960"/>
-          </a:xfrm>
-          <a:prstGeom prst="rect">
-            <a:avLst/>
-          </a:prstGeom>
-          <a:noFill/>
-        </p:spPr>
-        <p:txBody>
-          <a:bodyPr wrap="square" lIns="0" rIns="0" tIns="0" bIns="0" anchor="t">
-            <a:spAutoFit/>
-          </a:bodyPr>
-          <a:lstStyle/>
-          <a:p>
-            <a:pPr algn="l"/>
-            <a:r>
-              <a:rPr sz="1500" b="1" i="0">
-                <a:solidFill>
-                  <a:srgbClr val="3D3C3C"/>
-                </a:solidFill>
-                <a:latin typeface="Poppins"/>
-              </a:rPr>
-              <a:t>HSRA values guidance and capability</a:t>
-            </a:r>
-          </a:p>
-        </p:txBody>
-      </p:sp>
-      <p:sp>
-        <p:nvSpPr>
-          <p:cNvPr id="37" name="TextBox 36"/>
-          <p:cNvSpPr txBox="1"/>
-          <p:nvPr/>
-        </p:nvSpPr>
-        <p:spPr>
-          <a:xfrm>
-            <a:off x="4709160" y="3035808"/>
-            <a:ext cx="3383280" cy="868680"/>
-          </a:xfrm>
-          <a:prstGeom prst="rect">
-            <a:avLst/>
-          </a:prstGeom>
-          <a:noFill/>
-        </p:spPr>
-        <p:txBody>
-          <a:bodyPr wrap="square" lIns="0" rIns="0" tIns="0" bIns="0" anchor="t">
-            <a:spAutoFit/>
-          </a:bodyPr>
-          <a:lstStyle/>
-          <a:p>
-            <a:pPr algn="l"/>
-            <a:r>
-              <a:rPr sz="1150" b="0" i="0">
-                <a:solidFill>
-                  <a:srgbClr val="3D3C3C"/>
-                </a:solidFill>
-                <a:latin typeface="Poppins"/>
-              </a:rPr>
-              <a:t>HSRA is looking for as much guidance as possible and responds to partners who bring structure and clarity.</a:t>
-            </a:r>
-          </a:p>
-        </p:txBody>
-      </p:sp>
-      <p:sp>
-        <p:nvSpPr>
-          <p:cNvPr id="38" name="TextBox 37"/>
-          <p:cNvSpPr txBox="1"/>
-          <p:nvPr/>
-        </p:nvSpPr>
-        <p:spPr>
-          <a:xfrm>
-            <a:off x="8366760" y="3035808"/>
-            <a:ext cx="3273552" cy="868680"/>
-          </a:xfrm>
-          <a:prstGeom prst="rect">
-            <a:avLst/>
-          </a:prstGeom>
-          <a:noFill/>
-        </p:spPr>
-        <p:txBody>
-          <a:bodyPr wrap="square" lIns="0" rIns="0" tIns="0" bIns="0" anchor="t">
-            <a:spAutoFit/>
-          </a:bodyPr>
-          <a:lstStyle/>
-          <a:p>
-            <a:pPr algn="l"/>
-            <a:r>
-              <a:rPr sz="1100" b="0" i="1">
-                <a:solidFill>
-                  <a:srgbClr val="6E7178"/>
-                </a:solidFill>
-                <a:latin typeface="Poppins"/>
-              </a:rPr>
-              <a:t>In the Fire and Life Safety workshop, HSRA used GoFar's slides to run the meeting, as we had covered every point on its agenda.</a:t>
-            </a:r>
-          </a:p>
-        </p:txBody>
-      </p:sp>
-      <p:cxnSp>
-        <p:nvCxnSpPr>
-          <p:cNvPr id="39" name="Connector 38"/>
-          <p:cNvCxnSpPr/>
-          <p:nvPr/>
-        </p:nvCxnSpPr>
-        <p:spPr>
-          <a:xfrm>
-            <a:off x="548640" y="4023360"/>
-            <a:ext cx="11091672" cy="0"/>
-          </a:xfrm>
-          <a:prstGeom prst="line">
-            <a:avLst/>
-          </a:prstGeom>
-          <a:ln w="9525">
-            <a:solidFill>
-              <a:srgbClr val="D9DBE0"/>
-            </a:solidFill>
-          </a:ln>
-        </p:spPr>
-        <p:style>
-          <a:lnRef idx="2">
-            <a:schemeClr val="accent1"/>
-          </a:lnRef>
-          <a:fillRef idx="0">
-            <a:schemeClr val="accent1"/>
-          </a:fillRef>
-          <a:effectRef idx="1">
-            <a:schemeClr val="accent1"/>
-          </a:effectRef>
-          <a:fontRef idx="minor">
-            <a:schemeClr val="tx1"/>
-          </a:fontRef>
-        </p:style>
-      </p:cxnSp>
-      <p:sp>
-        <p:nvSpPr>
-          <p:cNvPr id="40" name="TextBox 39"/>
-          <p:cNvSpPr txBox="1"/>
-          <p:nvPr/>
-        </p:nvSpPr>
-        <p:spPr>
-          <a:xfrm>
-            <a:off x="548640" y="4087368"/>
-            <a:ext cx="777240" cy="548640"/>
-          </a:xfrm>
-          <a:prstGeom prst="rect">
-            <a:avLst/>
-          </a:prstGeom>
-          <a:noFill/>
-        </p:spPr>
-        <p:txBody>
-          <a:bodyPr wrap="square" lIns="0" rIns="0" tIns="0" bIns="0" anchor="t">
-            <a:spAutoFit/>
-          </a:bodyPr>
-          <a:lstStyle/>
-          <a:p>
-            <a:pPr algn="l"/>
-            <a:r>
-              <a:rPr sz="3000" b="1" i="0">
-                <a:solidFill>
-                  <a:srgbClr val="2EB88A"/>
-                </a:solidFill>
-                <a:latin typeface="Poppins"/>
-              </a:rPr>
-              <a:t>03</a:t>
-            </a:r>
-          </a:p>
-        </p:txBody>
-      </p:sp>
-      <p:sp>
-        <p:nvSpPr>
-          <p:cNvPr id="41" name="TextBox 40"/>
-          <p:cNvSpPr txBox="1"/>
-          <p:nvPr/>
-        </p:nvSpPr>
-        <p:spPr>
-          <a:xfrm>
-            <a:off x="1417320" y="4133087"/>
-            <a:ext cx="3108960" cy="822960"/>
-          </a:xfrm>
-          <a:prstGeom prst="rect">
-            <a:avLst/>
-          </a:prstGeom>
-          <a:noFill/>
-        </p:spPr>
-        <p:txBody>
-          <a:bodyPr wrap="square" lIns="0" rIns="0" tIns="0" bIns="0" anchor="t">
-            <a:spAutoFit/>
-          </a:bodyPr>
-          <a:lstStyle/>
-          <a:p>
-            <a:pPr algn="l"/>
-            <a:r>
-              <a:rPr sz="1500" b="1" i="0">
-                <a:solidFill>
-                  <a:srgbClr val="3D3C3C"/>
-                </a:solidFill>
-                <a:latin typeface="Poppins"/>
-              </a:rPr>
-              <a:t>Listening builds credibility</a:t>
-            </a:r>
-          </a:p>
-        </p:txBody>
-      </p:sp>
-      <p:sp>
-        <p:nvSpPr>
-          <p:cNvPr id="42" name="TextBox 41"/>
-          <p:cNvSpPr txBox="1"/>
-          <p:nvPr/>
-        </p:nvSpPr>
-        <p:spPr>
-          <a:xfrm>
-            <a:off x="4709160" y="4133087"/>
-            <a:ext cx="3383280" cy="868680"/>
-          </a:xfrm>
-          <a:prstGeom prst="rect">
-            <a:avLst/>
-          </a:prstGeom>
-          <a:noFill/>
-        </p:spPr>
-        <p:txBody>
-          <a:bodyPr wrap="square" lIns="0" rIns="0" tIns="0" bIns="0" anchor="t">
-            <a:spAutoFit/>
-          </a:bodyPr>
-          <a:lstStyle/>
-          <a:p>
-            <a:pPr algn="l"/>
-            <a:r>
-              <a:rPr sz="1150" b="0" i="0">
-                <a:solidFill>
-                  <a:srgbClr val="3D3C3C"/>
-                </a:solidFill>
-                <a:latin typeface="Poppins"/>
-              </a:rPr>
-              <a:t>Responding to what HSRA has asked for, and building on its own work, earns more trust than innovation for its own sake.</a:t>
-            </a:r>
-          </a:p>
-        </p:txBody>
-      </p:sp>
-      <p:sp>
-        <p:nvSpPr>
-          <p:cNvPr id="43" name="TextBox 42"/>
-          <p:cNvSpPr txBox="1"/>
-          <p:nvPr/>
-        </p:nvSpPr>
-        <p:spPr>
-          <a:xfrm>
-            <a:off x="8366760" y="4133087"/>
-            <a:ext cx="3273552" cy="868680"/>
-          </a:xfrm>
-          <a:prstGeom prst="rect">
-            <a:avLst/>
-          </a:prstGeom>
-          <a:noFill/>
-        </p:spPr>
-        <p:txBody>
-          <a:bodyPr wrap="square" lIns="0" rIns="0" tIns="0" bIns="0" anchor="t">
-            <a:spAutoFit/>
-          </a:bodyPr>
-          <a:lstStyle/>
-          <a:p>
-            <a:pPr algn="l"/>
-            <a:r>
-              <a:rPr sz="1100" b="0" i="1">
-                <a:solidFill>
-                  <a:srgbClr val="6E7178"/>
-                </a:solidFill>
-                <a:latin typeface="Poppins"/>
-              </a:rPr>
-              <a:t>The alternative alignment gained support because it built on HSRA's Business Case. Another partner's late, untested idea did not progress.</a:t>
-            </a:r>
-          </a:p>
-        </p:txBody>
-      </p:sp>
-      <p:cxnSp>
-        <p:nvCxnSpPr>
-          <p:cNvPr id="44" name="Connector 43"/>
-          <p:cNvCxnSpPr/>
-          <p:nvPr/>
-        </p:nvCxnSpPr>
-        <p:spPr>
-          <a:xfrm>
-            <a:off x="548640" y="5120640"/>
-            <a:ext cx="11091672" cy="0"/>
-          </a:xfrm>
-          <a:prstGeom prst="line">
-            <a:avLst/>
-          </a:prstGeom>
-          <a:ln w="9525">
-            <a:solidFill>
-              <a:srgbClr val="D9DBE0"/>
-            </a:solidFill>
-          </a:ln>
-        </p:spPr>
-        <p:style>
-          <a:lnRef idx="2">
-            <a:schemeClr val="accent1"/>
-          </a:lnRef>
-          <a:fillRef idx="0">
-            <a:schemeClr val="accent1"/>
-          </a:fillRef>
-          <a:effectRef idx="1">
-            <a:schemeClr val="accent1"/>
-          </a:effectRef>
-          <a:fontRef idx="minor">
-            <a:schemeClr val="tx1"/>
-          </a:fontRef>
-        </p:style>
-      </p:cxnSp>
-      <p:sp>
-        <p:nvSpPr>
-          <p:cNvPr id="45" name="TextBox 44"/>
-          <p:cNvSpPr txBox="1"/>
-          <p:nvPr/>
-        </p:nvSpPr>
-        <p:spPr>
-          <a:xfrm>
-            <a:off x="548640" y="5184648"/>
-            <a:ext cx="777240" cy="548640"/>
-          </a:xfrm>
-          <a:prstGeom prst="rect">
-            <a:avLst/>
-          </a:prstGeom>
-          <a:noFill/>
-        </p:spPr>
-        <p:txBody>
-          <a:bodyPr wrap="square" lIns="0" rIns="0" tIns="0" bIns="0" anchor="t">
-            <a:spAutoFit/>
-          </a:bodyPr>
-          <a:lstStyle/>
-          <a:p>
-            <a:pPr algn="l"/>
-            <a:r>
-              <a:rPr sz="3000" b="1" i="0">
-                <a:solidFill>
-                  <a:srgbClr val="EE2B7A"/>
-                </a:solidFill>
-                <a:latin typeface="Poppins"/>
-              </a:rPr>
-              <a:t>04</a:t>
-            </a:r>
-          </a:p>
-        </p:txBody>
-      </p:sp>
-      <p:sp>
-        <p:nvSpPr>
-          <p:cNvPr id="46" name="TextBox 45"/>
-          <p:cNvSpPr txBox="1"/>
-          <p:nvPr/>
-        </p:nvSpPr>
-        <p:spPr>
-          <a:xfrm>
-            <a:off x="1417320" y="5230368"/>
-            <a:ext cx="3108960" cy="822960"/>
-          </a:xfrm>
-          <a:prstGeom prst="rect">
-            <a:avLst/>
-          </a:prstGeom>
-          <a:noFill/>
-        </p:spPr>
-        <p:txBody>
-          <a:bodyPr wrap="square" lIns="0" rIns="0" tIns="0" bIns="0" anchor="t">
-            <a:spAutoFit/>
-          </a:bodyPr>
-          <a:lstStyle/>
-          <a:p>
-            <a:pPr algn="l"/>
-            <a:r>
-              <a:rPr sz="1500" b="1" i="0">
-                <a:solidFill>
-                  <a:srgbClr val="EE2B7A"/>
-                </a:solidFill>
-                <a:latin typeface="Poppins"/>
-              </a:rPr>
-              <a:t>Our secret sauce: HSRA at the centre</a:t>
-            </a:r>
-          </a:p>
-        </p:txBody>
-      </p:sp>
-      <p:sp>
-        <p:nvSpPr>
-          <p:cNvPr id="47" name="TextBox 46"/>
-          <p:cNvSpPr txBox="1"/>
-          <p:nvPr/>
-        </p:nvSpPr>
-        <p:spPr>
-          <a:xfrm>
-            <a:off x="4709160" y="5230368"/>
-            <a:ext cx="3383280" cy="868680"/>
-          </a:xfrm>
-          <a:prstGeom prst="rect">
-            <a:avLst/>
-          </a:prstGeom>
-          <a:noFill/>
-        </p:spPr>
-        <p:txBody>
-          <a:bodyPr wrap="square" lIns="0" rIns="0" tIns="0" bIns="0" anchor="t">
-            <a:spAutoFit/>
-          </a:bodyPr>
-          <a:lstStyle/>
-          <a:p>
-            <a:pPr algn="l"/>
-            <a:r>
-              <a:rPr sz="1150" b="0" i="0">
-                <a:solidFill>
-                  <a:srgbClr val="3D3C3C"/>
-                </a:solidFill>
-                <a:latin typeface="Poppins"/>
-              </a:rPr>
-              <a:t>Customer centricity sets GoFar apart. Every message starts with what HSRA needs, and we will keep building on it in the ECI.</a:t>
-            </a:r>
-          </a:p>
-        </p:txBody>
-      </p:sp>
-      <p:sp>
-        <p:nvSpPr>
-          <p:cNvPr id="48" name="TextBox 47"/>
-          <p:cNvSpPr txBox="1"/>
-          <p:nvPr/>
-        </p:nvSpPr>
-        <p:spPr>
-          <a:xfrm>
-            <a:off x="8366760" y="5230368"/>
-            <a:ext cx="3273552" cy="868680"/>
-          </a:xfrm>
-          <a:prstGeom prst="rect">
-            <a:avLst/>
-          </a:prstGeom>
-          <a:noFill/>
-        </p:spPr>
-        <p:txBody>
-          <a:bodyPr wrap="square" lIns="0" rIns="0" tIns="0" bIns="0" anchor="t">
-            <a:spAutoFit/>
-          </a:bodyPr>
-          <a:lstStyle/>
-          <a:p>
-            <a:pPr algn="l"/>
-            <a:r>
-              <a:rPr sz="1100" b="0" i="1">
-                <a:solidFill>
-                  <a:srgbClr val="6E7178"/>
-                </a:solidFill>
-                <a:latin typeface="Poppins"/>
-              </a:rPr>
-              <a:t>By linking every point to HSRA's benefit, the alternative alignment became known as the GoFar alignment and gained other partners' support.</a:t>
-            </a:r>
-          </a:p>
-        </p:txBody>
-      </p:sp>
-    </p:spTree>
-  </p:cSld>
-  <p:clrMapOvr>
-    <a:masterClrMapping/>
-  </p:clrMapOvr>
-</p:sld>
-</file>
-
-<file path=ppt/slides/slide9.xml><?xml version="1.0" encoding="utf-8"?>
-<p:sld xmlns:a="http://schemas.openxmlformats.org/drawingml/2006/main" xmlns:r="http://schemas.openxmlformats.org/officeDocument/2006/relationships" xmlns:p="http://schemas.openxmlformats.org/presentationml/2006/main">
-  <p:cSld>
-    <p:spTree>
-      <p:nvGrpSpPr>
-        <p:cNvPr id="1" name=""/>
-        <p:cNvGrpSpPr/>
-        <p:nvPr/>
-      </p:nvGrpSpPr>
-      <p:grpSpPr>
-        <a:xfrm>
-          <a:off x="0" y="0"/>
-          <a:ext cx="0" cy="0"/>
-          <a:chOff x="0" y="0"/>
-          <a:chExt cx="0" cy="0"/>
-        </a:xfrm>
-      </p:grpSpPr>
-      <p:sp>
-        <p:nvSpPr>
-          <p:cNvPr id="3" name="Text 0"/>
-          <p:cNvSpPr>
-            <a:spLocks noGrp="1"/>
-          </p:cNvSpPr>
-          <p:nvPr>
-            <p:ph type="title" idx="101" hasCustomPrompt="1"/>
-          </p:nvPr>
-        </p:nvSpPr>
-        <p:spPr>
-          <a:xfrm>
-            <a:off x="548640" y="658368"/>
-            <a:ext cx="11094415" cy="640080"/>
-          </a:xfrm>
-          <a:prstGeom prst="rect">
-            <a:avLst/>
-          </a:prstGeom>
-          <a:noFill/>
-          <a:ln/>
-        </p:spPr>
-        <p:txBody>
-          <a:bodyPr wrap="square" lIns="0" tIns="0" rIns="0" bIns="0" rtlCol="0" anchor="t"/>
-          <a:lstStyle/>
-          <a:p>
-            <a:r>
-              <a:rPr lang="en-AU" dirty="0"/>
-              <a:t>What we have heard and seen through the C&amp;V Phase</a:t>
-            </a:r>
-            <a:endParaRPr lang="en-US" sz="2800" dirty="0"/>
-          </a:p>
-        </p:txBody>
-      </p:sp>
-      <p:sp>
-        <p:nvSpPr>
-          <p:cNvPr id="32" name="Slide Number Placeholder 0"/>
-          <p:cNvSpPr>
-            <a:spLocks noGrp="1"/>
-          </p:cNvSpPr>
-          <p:nvPr>
-            <p:ph type="sldNum" sz="quarter" idx="4294967295"/>
-          </p:nvPr>
-        </p:nvSpPr>
-        <p:spPr>
-          <a:xfrm>
-            <a:off x="11259007" y="6327648"/>
-            <a:ext cx="384048" cy="274320"/>
-          </a:xfrm>
-          <a:prstGeom prst="rect">
-            <a:avLst/>
-          </a:prstGeom>
-          <a:extLst>
-            <a:ext uri="{C572A759-6A51-4108-AA02-DFA0A04FC94B}">
-              <ma14:wrappingTextBoxFlag xmlns:ma14="http://schemas.microsoft.com/office/mac/drawingml/2011/main" xmlns="" val="0"/>
-            </a:ext>
-          </a:extLst>
-        </p:spPr>
-        <p:txBody>
-          <a:bodyPr lIns="0" tIns="0" rIns="0" bIns="0" anchor="ctr"/>
-          <a:lstStyle>
-            <a:lvl1pPr>
-              <a:defRPr sz="1000">
-                <a:solidFill>
-                  <a:srgbClr val="FFFFFF"/>
-                </a:solidFill>
-              </a:defRPr>
-            </a:lvl1pPr>
-          </a:lstStyle>
-          <a:p>
-            <a:pPr marL="0" marR="0" lvl="0" indent="0" algn="ctr" defTabSz="914400" rtl="0" eaLnBrk="1" fontAlgn="auto" latinLnBrk="0" hangingPunct="1">
-              <a:lnSpc>
-                <a:spcPct val="100000"/>
-              </a:lnSpc>
-              <a:spcBef>
-                <a:spcPts val="0"/>
-              </a:spcBef>
-              <a:spcAft>
-                <a:spcPts val="0"/>
-              </a:spcAft>
-              <a:buClrTx/>
-              <a:buSzTx/>
-              <a:buFontTx/>
-              <a:buNone/>
-              <a:tabLst/>
-              <a:defRPr/>
-            </a:pPr>
-            <a:fld id="{F7021451-1387-4CA6-816F-3879F97B5CBC}" type="slidenum">
-              <a:rPr kumimoji="0" lang="en-US" sz="1000" b="0" i="0" u="none" strike="noStrike" kern="1200" cap="none" spc="0" normalizeH="0" baseline="0" noProof="0">
-                <a:ln>
-                  <a:noFill/>
-                </a:ln>
-                <a:solidFill>
-                  <a:srgbClr val="FFFFFF"/>
-                </a:solidFill>
-                <a:effectLst/>
-                <a:uLnTx/>
-                <a:uFillTx/>
-                <a:latin typeface="Poppins"/>
-                <a:ea typeface="+mn-ea"/>
-                <a:cs typeface="+mn-cs"/>
-              </a:rPr>
-              <a:pPr marL="0" marR="0" lvl="0" indent="0" algn="ctr" defTabSz="914400" rtl="0" eaLnBrk="1" fontAlgn="auto" latinLnBrk="0" hangingPunct="1">
-                <a:lnSpc>
-                  <a:spcPct val="100000"/>
-                </a:lnSpc>
-                <a:spcBef>
-                  <a:spcPts val="0"/>
-                </a:spcBef>
-                <a:spcAft>
-                  <a:spcPts val="0"/>
-                </a:spcAft>
-                <a:buClrTx/>
-                <a:buSzTx/>
-                <a:buFontTx/>
-                <a:buNone/>
-                <a:tabLst/>
-                <a:defRPr/>
-              </a:pPr>
-              <a:t>9</a:t>
-            </a:fld>
-            <a:endParaRPr kumimoji="0" lang="en-US" sz="1000" b="0" i="0" u="none" strike="noStrike" kern="1200" cap="none" spc="0" normalizeH="0" baseline="0" noProof="0">
-              <a:ln>
-                <a:noFill/>
-              </a:ln>
-              <a:solidFill>
-                <a:srgbClr val="FFFFFF"/>
-              </a:solidFill>
-              <a:effectLst/>
-              <a:uLnTx/>
-              <a:uFillTx/>
-              <a:latin typeface="Poppins"/>
-              <a:ea typeface="+mn-ea"/>
-              <a:cs typeface="+mn-cs"/>
-            </a:endParaRPr>
-          </a:p>
-        </p:txBody>
-      </p:sp>
-      <p:sp>
-        <p:nvSpPr>
-          <p:cNvPr id="33" name="TextBox 32"/>
-          <p:cNvSpPr txBox="1"/>
-          <p:nvPr/>
-        </p:nvSpPr>
-        <p:spPr>
-          <a:xfrm>
-            <a:off x="548640" y="1234440"/>
-            <a:ext cx="11091672" cy="365760"/>
-          </a:xfrm>
-          <a:prstGeom prst="rect">
-            <a:avLst/>
-          </a:prstGeom>
-          <a:noFill/>
-        </p:spPr>
-        <p:txBody>
-          <a:bodyPr wrap="square" lIns="0" rIns="0" tIns="0" bIns="0" anchor="t">
-            <a:spAutoFit/>
-          </a:bodyPr>
-          <a:lstStyle/>
-          <a:p>
-            <a:pPr algn="l"/>
-            <a:r>
-              <a:rPr sz="1400" b="0" i="0">
-                <a:solidFill>
-                  <a:srgbClr val="6E7178"/>
-                </a:solidFill>
-                <a:latin typeface="Poppins"/>
-              </a:rPr>
-              <a:t>The JV has made strong progress. A few changes now will set the team up well for the ECI Phase.</a:t>
-            </a:r>
-          </a:p>
-        </p:txBody>
-      </p:sp>
-      <p:sp>
-        <p:nvSpPr>
-          <p:cNvPr id="34" name="TextBox 33"/>
-          <p:cNvSpPr txBox="1"/>
-          <p:nvPr/>
-        </p:nvSpPr>
-        <p:spPr>
-          <a:xfrm>
-            <a:off x="548640" y="1828800"/>
-            <a:ext cx="3566160" cy="256032"/>
-          </a:xfrm>
-          <a:prstGeom prst="rect">
-            <a:avLst/>
-          </a:prstGeom>
-          <a:noFill/>
-        </p:spPr>
-        <p:txBody>
-          <a:bodyPr wrap="square" lIns="0" rIns="0" tIns="0" bIns="0" anchor="t">
-            <a:spAutoFit/>
-          </a:bodyPr>
-          <a:lstStyle/>
-          <a:p>
-            <a:pPr algn="l"/>
-            <a:r>
-              <a:rPr sz="1050" b="1" i="0" spc="150">
-                <a:solidFill>
-                  <a:srgbClr val="2EB88A"/>
-                </a:solidFill>
-                <a:latin typeface="Poppins"/>
-              </a:rPr>
-              <a:t>WHAT IS WORKING</a:t>
-            </a:r>
-          </a:p>
-        </p:txBody>
-      </p:sp>
-      <p:cxnSp>
-        <p:nvCxnSpPr>
-          <p:cNvPr id="35" name="Connector 34"/>
-          <p:cNvCxnSpPr/>
-          <p:nvPr/>
-        </p:nvCxnSpPr>
-        <p:spPr>
-          <a:xfrm>
-            <a:off x="548640" y="2130552"/>
-            <a:ext cx="3566160" cy="0"/>
-          </a:xfrm>
-          <a:prstGeom prst="line">
-            <a:avLst/>
-          </a:prstGeom>
-          <a:ln w="12700">
-            <a:solidFill>
-              <a:srgbClr val="3D3C3C"/>
-            </a:solidFill>
-          </a:ln>
-        </p:spPr>
-        <p:style>
-          <a:lnRef idx="2">
-            <a:schemeClr val="accent1"/>
-          </a:lnRef>
-          <a:fillRef idx="0">
-            <a:schemeClr val="accent1"/>
-          </a:fillRef>
-          <a:effectRef idx="1">
-            <a:schemeClr val="accent1"/>
-          </a:effectRef>
-          <a:fontRef idx="minor">
-            <a:schemeClr val="tx1"/>
-          </a:fontRef>
-        </p:style>
-      </p:cxnSp>
-      <p:sp>
-        <p:nvSpPr>
-          <p:cNvPr id="36" name="TextBox 35"/>
-          <p:cNvSpPr txBox="1"/>
-          <p:nvPr/>
-        </p:nvSpPr>
-        <p:spPr>
-          <a:xfrm>
-            <a:off x="548640" y="2286000"/>
-            <a:ext cx="3566160" cy="868680"/>
-          </a:xfrm>
-          <a:prstGeom prst="rect">
-            <a:avLst/>
-          </a:prstGeom>
-          <a:noFill/>
-        </p:spPr>
-        <p:txBody>
-          <a:bodyPr wrap="square" lIns="0" rIns="0" tIns="0" bIns="0" anchor="t">
-            <a:spAutoFit/>
-          </a:bodyPr>
-          <a:lstStyle/>
-          <a:p>
-            <a:pPr algn="l"/>
-            <a:r>
-              <a:rPr sz="1250" b="1" i="0">
-                <a:solidFill>
-                  <a:srgbClr val="3D3C3C"/>
-                </a:solidFill>
-                <a:latin typeface="Poppins"/>
-              </a:rPr>
-              <a:t>Context before the solution</a:t>
-            </a:r>
-          </a:p>
-          <a:p>
-            <a:pPr algn="l"/>
-            <a:r>
-              <a:rPr sz="1150" b="0" i="0">
-                <a:solidFill>
-                  <a:srgbClr val="6E7178"/>
-                </a:solidFill>
-                <a:latin typeface="Poppins"/>
-              </a:rPr>
-              <a:t>Framing each idea around HSRA's needs made complex proposals easy to support.</a:t>
-            </a:r>
-          </a:p>
-        </p:txBody>
-      </p:sp>
-      <p:cxnSp>
-        <p:nvCxnSpPr>
-          <p:cNvPr id="37" name="Connector 36"/>
-          <p:cNvCxnSpPr/>
-          <p:nvPr/>
-        </p:nvCxnSpPr>
-        <p:spPr>
-          <a:xfrm>
-            <a:off x="548640" y="3136392"/>
-            <a:ext cx="3566160" cy="0"/>
-          </a:xfrm>
-          <a:prstGeom prst="line">
-            <a:avLst/>
-          </a:prstGeom>
-          <a:ln w="9525">
-            <a:solidFill>
-              <a:srgbClr val="D9DBE0"/>
-            </a:solidFill>
-          </a:ln>
-        </p:spPr>
-        <p:style>
-          <a:lnRef idx="2">
-            <a:schemeClr val="accent1"/>
-          </a:lnRef>
-          <a:fillRef idx="0">
-            <a:schemeClr val="accent1"/>
-          </a:fillRef>
-          <a:effectRef idx="1">
-            <a:schemeClr val="accent1"/>
-          </a:effectRef>
-          <a:fontRef idx="minor">
-            <a:schemeClr val="tx1"/>
-          </a:fontRef>
-        </p:style>
-      </p:cxnSp>
-      <p:sp>
-        <p:nvSpPr>
-          <p:cNvPr id="38" name="TextBox 37"/>
-          <p:cNvSpPr txBox="1"/>
-          <p:nvPr/>
-        </p:nvSpPr>
-        <p:spPr>
-          <a:xfrm>
-            <a:off x="548640" y="3246120"/>
-            <a:ext cx="3566160" cy="868680"/>
-          </a:xfrm>
-          <a:prstGeom prst="rect">
-            <a:avLst/>
-          </a:prstGeom>
-          <a:noFill/>
-        </p:spPr>
-        <p:txBody>
-          <a:bodyPr wrap="square" lIns="0" rIns="0" tIns="0" bIns="0" anchor="t">
-            <a:spAutoFit/>
-          </a:bodyPr>
-          <a:lstStyle/>
-          <a:p>
-            <a:pPr algn="l"/>
-            <a:r>
-              <a:rPr sz="1250" b="1" i="0">
-                <a:solidFill>
-                  <a:srgbClr val="3D3C3C"/>
-                </a:solidFill>
-                <a:latin typeface="Poppins"/>
-              </a:rPr>
-              <a:t>Clear, simple messages</a:t>
-            </a:r>
-          </a:p>
-          <a:p>
-            <a:pPr algn="l"/>
-            <a:r>
-              <a:rPr sz="1150" b="0" i="0">
-                <a:solidFill>
-                  <a:srgbClr val="6E7178"/>
-                </a:solidFill>
-                <a:latin typeface="Poppins"/>
-              </a:rPr>
-              <a:t>Distilling technical material into a few client-relevant points helped HSRA adopt our thinking.</a:t>
-            </a:r>
-          </a:p>
-        </p:txBody>
-      </p:sp>
-      <p:cxnSp>
-        <p:nvCxnSpPr>
-          <p:cNvPr id="39" name="Connector 38"/>
-          <p:cNvCxnSpPr/>
-          <p:nvPr/>
-        </p:nvCxnSpPr>
-        <p:spPr>
-          <a:xfrm>
-            <a:off x="548640" y="4096511"/>
-            <a:ext cx="3566160" cy="0"/>
-          </a:xfrm>
-          <a:prstGeom prst="line">
-            <a:avLst/>
-          </a:prstGeom>
-          <a:ln w="9525">
-            <a:solidFill>
-              <a:srgbClr val="D9DBE0"/>
-            </a:solidFill>
-          </a:ln>
-        </p:spPr>
-        <p:style>
-          <a:lnRef idx="2">
-            <a:schemeClr val="accent1"/>
-          </a:lnRef>
-          <a:fillRef idx="0">
-            <a:schemeClr val="accent1"/>
-          </a:fillRef>
-          <a:effectRef idx="1">
-            <a:schemeClr val="accent1"/>
-          </a:effectRef>
-          <a:fontRef idx="minor">
-            <a:schemeClr val="tx1"/>
-          </a:fontRef>
-        </p:style>
-      </p:cxnSp>
-      <p:sp>
-        <p:nvSpPr>
-          <p:cNvPr id="40" name="TextBox 39"/>
-          <p:cNvSpPr txBox="1"/>
-          <p:nvPr/>
-        </p:nvSpPr>
-        <p:spPr>
-          <a:xfrm>
-            <a:off x="548640" y="4206240"/>
-            <a:ext cx="3566160" cy="868680"/>
-          </a:xfrm>
-          <a:prstGeom prst="rect">
-            <a:avLst/>
-          </a:prstGeom>
-          <a:noFill/>
-        </p:spPr>
-        <p:txBody>
-          <a:bodyPr wrap="square" lIns="0" rIns="0" tIns="0" bIns="0" anchor="t">
-            <a:spAutoFit/>
-          </a:bodyPr>
-          <a:lstStyle/>
-          <a:p>
-            <a:pPr algn="l"/>
-            <a:r>
-              <a:rPr sz="1250" b="1" i="0">
-                <a:solidFill>
-                  <a:srgbClr val="3D3C3C"/>
-                </a:solidFill>
-                <a:latin typeface="Poppins"/>
-              </a:rPr>
-              <a:t>A strong presence</a:t>
-            </a:r>
-          </a:p>
-          <a:p>
-            <a:pPr algn="l"/>
-            <a:r>
-              <a:rPr sz="1150" b="0" i="0">
-                <a:solidFill>
-                  <a:srgbClr val="6E7178"/>
-                </a:solidFill>
-                <a:latin typeface="Poppins"/>
-              </a:rPr>
-              <a:t>Engaged, consistent body language made GoFar visibly the strongest ECI partner.</a:t>
-            </a:r>
-          </a:p>
-        </p:txBody>
-      </p:sp>
-      <p:sp>
-        <p:nvSpPr>
-          <p:cNvPr id="41" name="TextBox 40"/>
-          <p:cNvSpPr txBox="1"/>
-          <p:nvPr/>
-        </p:nvSpPr>
-        <p:spPr>
-          <a:xfrm>
-            <a:off x="4526280" y="1828800"/>
-            <a:ext cx="7114032" cy="256032"/>
-          </a:xfrm>
-          <a:prstGeom prst="rect">
-            <a:avLst/>
-          </a:prstGeom>
-          <a:noFill/>
-        </p:spPr>
-        <p:txBody>
-          <a:bodyPr wrap="square" lIns="0" rIns="0" tIns="0" bIns="0" anchor="t">
-            <a:spAutoFit/>
-          </a:bodyPr>
-          <a:lstStyle/>
-          <a:p>
-            <a:pPr algn="l"/>
-            <a:r>
-              <a:rPr sz="1050" b="1" i="0" spc="150">
-                <a:solidFill>
-                  <a:srgbClr val="F48047"/>
-                </a:solidFill>
-                <a:latin typeface="Poppins"/>
-              </a:rPr>
-              <a:t>WHAT NEEDS TO CHANGE BEFORE THE ECI</a:t>
-            </a:r>
-          </a:p>
-        </p:txBody>
-      </p:sp>
-      <p:cxnSp>
-        <p:nvCxnSpPr>
-          <p:cNvPr id="42" name="Connector 41"/>
-          <p:cNvCxnSpPr/>
-          <p:nvPr/>
-        </p:nvCxnSpPr>
-        <p:spPr>
-          <a:xfrm>
-            <a:off x="4526280" y="2130552"/>
-            <a:ext cx="7114032" cy="0"/>
-          </a:xfrm>
-          <a:prstGeom prst="line">
-            <a:avLst/>
-          </a:prstGeom>
-          <a:ln w="12700">
-            <a:solidFill>
-              <a:srgbClr val="3D3C3C"/>
-            </a:solidFill>
-          </a:ln>
-        </p:spPr>
-        <p:style>
-          <a:lnRef idx="2">
-            <a:schemeClr val="accent1"/>
-          </a:lnRef>
-          <a:fillRef idx="0">
-            <a:schemeClr val="accent1"/>
-          </a:fillRef>
-          <a:effectRef idx="1">
-            <a:schemeClr val="accent1"/>
-          </a:effectRef>
-          <a:fontRef idx="minor">
-            <a:schemeClr val="tx1"/>
-          </a:fontRef>
-        </p:style>
-      </p:cxnSp>
-      <p:sp>
-        <p:nvSpPr>
-          <p:cNvPr id="43" name="TextBox 42"/>
-          <p:cNvSpPr txBox="1"/>
-          <p:nvPr/>
-        </p:nvSpPr>
-        <p:spPr>
-          <a:xfrm>
-            <a:off x="4526280" y="2286000"/>
-            <a:ext cx="2011680" cy="777240"/>
-          </a:xfrm>
-          <a:prstGeom prst="rect">
-            <a:avLst/>
-          </a:prstGeom>
-          <a:noFill/>
-        </p:spPr>
-        <p:txBody>
-          <a:bodyPr wrap="square" lIns="0" rIns="0" tIns="0" bIns="0" anchor="t">
-            <a:spAutoFit/>
-          </a:bodyPr>
-          <a:lstStyle/>
-          <a:p>
-            <a:pPr algn="l"/>
-            <a:r>
-              <a:rPr sz="1250" b="1" i="0">
-                <a:solidFill>
-                  <a:srgbClr val="3D3C3C"/>
-                </a:solidFill>
-                <a:latin typeface="Poppins"/>
-              </a:rPr>
-              <a:t>A one-team culture</a:t>
-            </a:r>
-          </a:p>
-        </p:txBody>
-      </p:sp>
-      <p:sp>
-        <p:nvSpPr>
-          <p:cNvPr id="44" name="TextBox 43"/>
-          <p:cNvSpPr txBox="1"/>
-          <p:nvPr/>
-        </p:nvSpPr>
-        <p:spPr>
-          <a:xfrm>
-            <a:off x="6629400" y="2286000"/>
-            <a:ext cx="5010912" cy="777240"/>
-          </a:xfrm>
-          <a:prstGeom prst="rect">
-            <a:avLst/>
-          </a:prstGeom>
-          <a:noFill/>
-        </p:spPr>
-        <p:txBody>
-          <a:bodyPr wrap="square" lIns="0" rIns="0" tIns="0" bIns="0" anchor="t">
-            <a:spAutoFit/>
-          </a:bodyPr>
-          <a:lstStyle/>
-          <a:p>
-            <a:pPr algn="l"/>
-            <a:r>
-              <a:rPr sz="1150" b="0" i="0">
-                <a:solidFill>
-                  <a:srgbClr val="3D3C3C"/>
-                </a:solidFill>
-                <a:latin typeface="Poppins"/>
-              </a:rPr>
-              <a:t>The team works well together, but nothing yet ties the JV together as one team. The move to 100 Arthur Street is a great first step; a shared activity outside the office would help solidify that culture.</a:t>
-            </a:r>
-          </a:p>
-        </p:txBody>
-      </p:sp>
-      <p:cxnSp>
-        <p:nvCxnSpPr>
-          <p:cNvPr id="45" name="Connector 44"/>
-          <p:cNvCxnSpPr/>
-          <p:nvPr/>
-        </p:nvCxnSpPr>
-        <p:spPr>
-          <a:xfrm>
-            <a:off x="4526280" y="3063240"/>
-            <a:ext cx="7114032" cy="0"/>
-          </a:xfrm>
-          <a:prstGeom prst="line">
-            <a:avLst/>
-          </a:prstGeom>
-          <a:ln w="9525">
-            <a:solidFill>
-              <a:srgbClr val="D9DBE0"/>
-            </a:solidFill>
-          </a:ln>
-        </p:spPr>
-        <p:style>
-          <a:lnRef idx="2">
-            <a:schemeClr val="accent1"/>
-          </a:lnRef>
-          <a:fillRef idx="0">
-            <a:schemeClr val="accent1"/>
-          </a:fillRef>
-          <a:effectRef idx="1">
-            <a:schemeClr val="accent1"/>
-          </a:effectRef>
-          <a:fontRef idx="minor">
-            <a:schemeClr val="tx1"/>
-          </a:fontRef>
-        </p:style>
-      </p:cxnSp>
-      <p:sp>
-        <p:nvSpPr>
-          <p:cNvPr id="46" name="TextBox 45"/>
-          <p:cNvSpPr txBox="1"/>
-          <p:nvPr/>
-        </p:nvSpPr>
-        <p:spPr>
-          <a:xfrm>
-            <a:off x="4526280" y="3154680"/>
-            <a:ext cx="2011680" cy="777240"/>
-          </a:xfrm>
-          <a:prstGeom prst="rect">
-            <a:avLst/>
-          </a:prstGeom>
-          <a:noFill/>
-        </p:spPr>
-        <p:txBody>
-          <a:bodyPr wrap="square" lIns="0" rIns="0" tIns="0" bIns="0" anchor="t">
-            <a:spAutoFit/>
-          </a:bodyPr>
-          <a:lstStyle/>
-          <a:p>
-            <a:pPr algn="l"/>
-            <a:r>
-              <a:rPr sz="1250" b="1" i="0">
-                <a:solidFill>
-                  <a:srgbClr val="3D3C3C"/>
-                </a:solidFill>
-                <a:latin typeface="Poppins"/>
-              </a:rPr>
-              <a:t>Front-loaded preparation</a:t>
-            </a:r>
-          </a:p>
-        </p:txBody>
-      </p:sp>
-      <p:sp>
-        <p:nvSpPr>
-          <p:cNvPr id="47" name="TextBox 46"/>
-          <p:cNvSpPr txBox="1"/>
-          <p:nvPr/>
-        </p:nvSpPr>
-        <p:spPr>
-          <a:xfrm>
-            <a:off x="6629400" y="3154680"/>
-            <a:ext cx="5010912" cy="777240"/>
-          </a:xfrm>
-          <a:prstGeom prst="rect">
-            <a:avLst/>
-          </a:prstGeom>
-          <a:noFill/>
-        </p:spPr>
-        <p:txBody>
-          <a:bodyPr wrap="square" lIns="0" rIns="0" tIns="0" bIns="0" anchor="t">
-            <a:spAutoFit/>
-          </a:bodyPr>
-          <a:lstStyle/>
-          <a:p>
-            <a:pPr algn="l"/>
-            <a:r>
-              <a:rPr sz="1150" b="0" i="0">
-                <a:solidFill>
-                  <a:srgbClr val="3D3C3C"/>
-                </a:solidFill>
-                <a:latin typeface="Poppins"/>
-              </a:rPr>
-              <a:t>Day-before prep sessions leave little room to change anything and lead to late nights. In our approach, content is locked two days out, leaving the final two days for rehearsal and minor tweaks. This should be the ECI standard.</a:t>
-            </a:r>
-          </a:p>
-        </p:txBody>
-      </p:sp>
-      <p:cxnSp>
-        <p:nvCxnSpPr>
-          <p:cNvPr id="48" name="Connector 47"/>
-          <p:cNvCxnSpPr/>
-          <p:nvPr/>
-        </p:nvCxnSpPr>
-        <p:spPr>
-          <a:xfrm>
-            <a:off x="4526280" y="4023360"/>
-            <a:ext cx="7114032" cy="0"/>
-          </a:xfrm>
-          <a:prstGeom prst="line">
-            <a:avLst/>
-          </a:prstGeom>
-          <a:ln w="9525">
-            <a:solidFill>
-              <a:srgbClr val="D9DBE0"/>
-            </a:solidFill>
-          </a:ln>
-        </p:spPr>
-        <p:style>
-          <a:lnRef idx="2">
-            <a:schemeClr val="accent1"/>
-          </a:lnRef>
-          <a:fillRef idx="0">
-            <a:schemeClr val="accent1"/>
-          </a:fillRef>
-          <a:effectRef idx="1">
-            <a:schemeClr val="accent1"/>
-          </a:effectRef>
-          <a:fontRef idx="minor">
-            <a:schemeClr val="tx1"/>
-          </a:fontRef>
-        </p:style>
-      </p:cxnSp>
-      <p:sp>
-        <p:nvSpPr>
-          <p:cNvPr id="49" name="TextBox 48"/>
-          <p:cNvSpPr txBox="1"/>
-          <p:nvPr/>
-        </p:nvSpPr>
-        <p:spPr>
-          <a:xfrm>
-            <a:off x="4526280" y="4114800"/>
-            <a:ext cx="2011680" cy="548640"/>
-          </a:xfrm>
-          <a:prstGeom prst="rect">
-            <a:avLst/>
-          </a:prstGeom>
-          <a:noFill/>
-        </p:spPr>
-        <p:txBody>
-          <a:bodyPr wrap="square" lIns="0" rIns="0" tIns="0" bIns="0" anchor="t">
-            <a:spAutoFit/>
-          </a:bodyPr>
-          <a:lstStyle/>
-          <a:p>
-            <a:pPr algn="l"/>
-            <a:r>
-              <a:rPr sz="1250" b="1" i="0">
-                <a:solidFill>
-                  <a:srgbClr val="3D3C3C"/>
-                </a:solidFill>
-                <a:latin typeface="Poppins"/>
-              </a:rPr>
-              <a:t>One agreed position</a:t>
-            </a:r>
-          </a:p>
-        </p:txBody>
-      </p:sp>
-      <p:sp>
-        <p:nvSpPr>
-          <p:cNvPr id="50" name="TextBox 49"/>
-          <p:cNvSpPr txBox="1"/>
-          <p:nvPr/>
-        </p:nvSpPr>
-        <p:spPr>
-          <a:xfrm>
-            <a:off x="6629400" y="4114800"/>
-            <a:ext cx="5010912" cy="548640"/>
-          </a:xfrm>
-          <a:prstGeom prst="rect">
-            <a:avLst/>
-          </a:prstGeom>
-          <a:noFill/>
-        </p:spPr>
-        <p:txBody>
-          <a:bodyPr wrap="square" lIns="0" rIns="0" tIns="0" bIns="0" anchor="t">
-            <a:spAutoFit/>
-          </a:bodyPr>
-          <a:lstStyle/>
-          <a:p>
-            <a:pPr algn="l"/>
-            <a:r>
-              <a:rPr sz="1150" b="0" i="0">
-                <a:solidFill>
-                  <a:srgbClr val="3D3C3C"/>
-                </a:solidFill>
-                <a:latin typeface="Poppins"/>
-              </a:rPr>
-              <a:t>Share a weekly update on the latest design position, and raise concerns early rather than defaulting to yes.</a:t>
-            </a:r>
-          </a:p>
-        </p:txBody>
-      </p:sp>
-      <p:cxnSp>
-        <p:nvCxnSpPr>
-          <p:cNvPr id="51" name="Connector 50"/>
-          <p:cNvCxnSpPr/>
-          <p:nvPr/>
-        </p:nvCxnSpPr>
-        <p:spPr>
-          <a:xfrm>
-            <a:off x="4526280" y="4590288"/>
-            <a:ext cx="7114032" cy="0"/>
-          </a:xfrm>
-          <a:prstGeom prst="line">
-            <a:avLst/>
-          </a:prstGeom>
-          <a:ln w="9525">
-            <a:solidFill>
-              <a:srgbClr val="D9DBE0"/>
-            </a:solidFill>
-          </a:ln>
-        </p:spPr>
-        <p:style>
-          <a:lnRef idx="2">
-            <a:schemeClr val="accent1"/>
-          </a:lnRef>
-          <a:fillRef idx="0">
-            <a:schemeClr val="accent1"/>
-          </a:fillRef>
-          <a:effectRef idx="1">
-            <a:schemeClr val="accent1"/>
-          </a:effectRef>
-          <a:fontRef idx="minor">
-            <a:schemeClr val="tx1"/>
-          </a:fontRef>
-        </p:style>
-      </p:cxnSp>
-      <p:sp>
-        <p:nvSpPr>
-          <p:cNvPr id="52" name="TextBox 51"/>
-          <p:cNvSpPr txBox="1"/>
-          <p:nvPr/>
-        </p:nvSpPr>
-        <p:spPr>
-          <a:xfrm>
-            <a:off x="4526280" y="4681728"/>
-            <a:ext cx="2011680" cy="548640"/>
-          </a:xfrm>
-          <a:prstGeom prst="rect">
-            <a:avLst/>
-          </a:prstGeom>
-          <a:noFill/>
-        </p:spPr>
-        <p:txBody>
-          <a:bodyPr wrap="square" lIns="0" rIns="0" tIns="0" bIns="0" anchor="t">
-            <a:spAutoFit/>
-          </a:bodyPr>
-          <a:lstStyle/>
-          <a:p>
-            <a:pPr algn="l"/>
-            <a:r>
-              <a:rPr sz="1250" b="1" i="0">
-                <a:solidFill>
-                  <a:srgbClr val="3D3C3C"/>
-                </a:solidFill>
-                <a:latin typeface="Poppins"/>
-              </a:rPr>
-              <a:t>Focus and continuity</a:t>
-            </a:r>
-          </a:p>
-        </p:txBody>
-      </p:sp>
-      <p:sp>
-        <p:nvSpPr>
-          <p:cNvPr id="53" name="TextBox 52"/>
-          <p:cNvSpPr txBox="1"/>
-          <p:nvPr/>
-        </p:nvSpPr>
-        <p:spPr>
-          <a:xfrm>
-            <a:off x="6629400" y="4681728"/>
-            <a:ext cx="5010912" cy="548640"/>
-          </a:xfrm>
-          <a:prstGeom prst="rect">
-            <a:avLst/>
-          </a:prstGeom>
-          <a:noFill/>
-        </p:spPr>
-        <p:txBody>
-          <a:bodyPr wrap="square" lIns="0" rIns="0" tIns="0" bIns="0" anchor="t">
-            <a:spAutoFit/>
-          </a:bodyPr>
-          <a:lstStyle/>
-          <a:p>
-            <a:pPr algn="l"/>
-            <a:r>
-              <a:rPr sz="1150" b="0" i="0">
-                <a:solidFill>
-                  <a:srgbClr val="3D3C3C"/>
-                </a:solidFill>
-                <a:latin typeface="Poppins"/>
-              </a:rPr>
-              <a:t>Track HSRA's requests in one place, keep consistent faces across sessions, and present a few focused slides with detail in reserve.</a:t>
-            </a:r>
-          </a:p>
-        </p:txBody>
-      </p:sp>
-      <p:cxnSp>
-        <p:nvCxnSpPr>
-          <p:cNvPr id="54" name="Connector 53"/>
-          <p:cNvCxnSpPr/>
-          <p:nvPr/>
-        </p:nvCxnSpPr>
-        <p:spPr>
-          <a:xfrm>
-            <a:off x="548640" y="5413248"/>
-            <a:ext cx="11091672" cy="0"/>
-          </a:xfrm>
-          <a:prstGeom prst="line">
-            <a:avLst/>
-          </a:prstGeom>
-          <a:ln w="12700">
-            <a:solidFill>
-              <a:srgbClr val="3D3C3C"/>
-            </a:solidFill>
-          </a:ln>
-        </p:spPr>
-        <p:style>
-          <a:lnRef idx="2">
-            <a:schemeClr val="accent1"/>
-          </a:lnRef>
-          <a:fillRef idx="0">
-            <a:schemeClr val="accent1"/>
-          </a:fillRef>
-          <a:effectRef idx="1">
-            <a:schemeClr val="accent1"/>
-          </a:effectRef>
-          <a:fontRef idx="minor">
-            <a:schemeClr val="tx1"/>
-          </a:fontRef>
-        </p:style>
-      </p:cxnSp>
-      <p:sp>
-        <p:nvSpPr>
-          <p:cNvPr id="55" name="TextBox 54"/>
-          <p:cNvSpPr txBox="1"/>
-          <p:nvPr/>
-        </p:nvSpPr>
-        <p:spPr>
-          <a:xfrm>
-            <a:off x="548640" y="5532120"/>
-            <a:ext cx="11091672" cy="365760"/>
-          </a:xfrm>
-          <a:prstGeom prst="rect">
-            <a:avLst/>
-          </a:prstGeom>
-          <a:noFill/>
-        </p:spPr>
-        <p:txBody>
-          <a:bodyPr wrap="square" lIns="0" rIns="0" tIns="0" bIns="0" anchor="t">
-            <a:spAutoFit/>
-          </a:bodyPr>
-          <a:lstStyle/>
-          <a:p>
-            <a:pPr algn="l"/>
-            <a:r>
-              <a:rPr sz="1300" b="1" i="0">
-                <a:solidFill>
-                  <a:srgbClr val="F48047"/>
-                </a:solidFill>
-                <a:latin typeface="Poppins"/>
-              </a:rPr>
-              <a:t>For discussion:  </a:t>
-            </a:r>
-            <a:r>
-              <a:rPr sz="1300" b="1" i="0">
-                <a:solidFill>
-                  <a:srgbClr val="3D3C3C"/>
-                </a:solidFill>
-                <a:latin typeface="Poppins"/>
-              </a:rPr>
-              <a:t>What else have you seen that we should address before the ECI Phase?</a:t>
             </a:r>
           </a:p>
         </p:txBody>

</xml_diff>